<commit_message>
Add sheng reed loop gates
</commit_message>
<xml_diff>
--- a/capstone-deck.pptx
+++ b/capstone-deck.pptx
@@ -1,31 +1,32 @@
 
 <file path=ppt/presentation.xml><?xml version="1.0" encoding="utf-8"?>
-<p:presentation xmlns:a="http://schemas.openxmlformats.org/drawingml/2006/main" xmlns:r="http://schemas.openxmlformats.org/officeDocument/2006/relationships" xmlns:p="http://schemas.openxmlformats.org/presentationml/2006/main" saveSubsetFonts="1" autoCompressPictures="0">
+<p:presentation xmlns:a="http://schemas.openxmlformats.org/drawingml/2006/main" xmlns:p="http://schemas.openxmlformats.org/presentationml/2006/main" xmlns:r="http://schemas.openxmlformats.org/officeDocument/2006/relationships" autoCompressPictures="0" saveSubsetFonts="1">
   <p:sldMasterIdLst>
     <p:sldMasterId id="2147483648" r:id="rId1"/>
   </p:sldMasterIdLst>
   <p:sldIdLst>
-    <p:sldId id="256" r:id="rId7"/>
-    <p:sldId id="257" r:id="rId8"/>
-    <p:sldId id="258" r:id="rId9"/>
-    <p:sldId id="259" r:id="rId10"/>
-    <p:sldId id="260" r:id="rId11"/>
-    <p:sldId id="261" r:id="rId12"/>
-    <p:sldId id="262" r:id="rId13"/>
-    <p:sldId id="263" r:id="rId14"/>
-    <p:sldId id="264" r:id="rId15"/>
-    <p:sldId id="265" r:id="rId16"/>
-    <p:sldId id="266" r:id="rId17"/>
-    <p:sldId id="267" r:id="rId18"/>
+    <p:sldId id="256" r:id="rId2"/>
+    <p:sldId id="257" r:id="rId3"/>
+    <p:sldId id="258" r:id="rId4"/>
+    <p:sldId id="259" r:id="rId5"/>
+    <p:sldId id="260" r:id="rId6"/>
+    <p:sldId id="261" r:id="rId7"/>
+    <p:sldId id="262" r:id="rId8"/>
+    <p:sldId id="263" r:id="rId9"/>
+    <p:sldId id="264" r:id="rId10"/>
+    <p:sldId id="265" r:id="rId11"/>
+    <p:sldId id="266" r:id="rId12"/>
+    <p:sldId id="267" r:id="rId13"/>
+    <p:sldId id="268" r:id="rId14"/>
   </p:sldIdLst>
-  <p:sldSz cx="9144000" cy="6858000" type="screen4x3"/>
+  <p:sldSz cx="9144000" cy="5143500" type="screen16x9"/>
   <p:notesSz cx="6858000" cy="9144000"/>
   <p:defaultTextStyle>
     <a:defPPr>
       <a:defRPr lang="en-US"/>
     </a:defPPr>
-    <a:lvl1pPr marL="0" algn="l" defTabSz="457200" rtl="0" eaLnBrk="1" latinLnBrk="0" hangingPunct="1">
-      <a:defRPr sz="1800" kern="1200">
+    <a:lvl1pPr algn="l" defTabSz="457200" eaLnBrk="1" hangingPunct="1" latinLnBrk="0" marL="0" rtl="0">
+      <a:defRPr kern="1200" sz="1800">
         <a:solidFill>
           <a:schemeClr val="tx1"/>
         </a:solidFill>
@@ -34,8 +35,8 @@
         <a:cs typeface="+mn-cs"/>
       </a:defRPr>
     </a:lvl1pPr>
-    <a:lvl2pPr marL="457200" algn="l" defTabSz="457200" rtl="0" eaLnBrk="1" latinLnBrk="0" hangingPunct="1">
-      <a:defRPr sz="1800" kern="1200">
+    <a:lvl2pPr algn="l" defTabSz="457200" eaLnBrk="1" hangingPunct="1" latinLnBrk="0" marL="457200" rtl="0">
+      <a:defRPr kern="1200" sz="1800">
         <a:solidFill>
           <a:schemeClr val="tx1"/>
         </a:solidFill>
@@ -44,8 +45,8 @@
         <a:cs typeface="+mn-cs"/>
       </a:defRPr>
     </a:lvl2pPr>
-    <a:lvl3pPr marL="914400" algn="l" defTabSz="457200" rtl="0" eaLnBrk="1" latinLnBrk="0" hangingPunct="1">
-      <a:defRPr sz="1800" kern="1200">
+    <a:lvl3pPr algn="l" defTabSz="457200" eaLnBrk="1" hangingPunct="1" latinLnBrk="0" marL="914400" rtl="0">
+      <a:defRPr kern="1200" sz="1800">
         <a:solidFill>
           <a:schemeClr val="tx1"/>
         </a:solidFill>
@@ -54,8 +55,8 @@
         <a:cs typeface="+mn-cs"/>
       </a:defRPr>
     </a:lvl3pPr>
-    <a:lvl4pPr marL="1371600" algn="l" defTabSz="457200" rtl="0" eaLnBrk="1" latinLnBrk="0" hangingPunct="1">
-      <a:defRPr sz="1800" kern="1200">
+    <a:lvl4pPr algn="l" defTabSz="457200" eaLnBrk="1" hangingPunct="1" latinLnBrk="0" marL="1371600" rtl="0">
+      <a:defRPr kern="1200" sz="1800">
         <a:solidFill>
           <a:schemeClr val="tx1"/>
         </a:solidFill>
@@ -64,8 +65,8 @@
         <a:cs typeface="+mn-cs"/>
       </a:defRPr>
     </a:lvl4pPr>
-    <a:lvl5pPr marL="1828800" algn="l" defTabSz="457200" rtl="0" eaLnBrk="1" latinLnBrk="0" hangingPunct="1">
-      <a:defRPr sz="1800" kern="1200">
+    <a:lvl5pPr algn="l" defTabSz="457200" eaLnBrk="1" hangingPunct="1" latinLnBrk="0" marL="1828800" rtl="0">
+      <a:defRPr kern="1200" sz="1800">
         <a:solidFill>
           <a:schemeClr val="tx1"/>
         </a:solidFill>
@@ -74,8 +75,8 @@
         <a:cs typeface="+mn-cs"/>
       </a:defRPr>
     </a:lvl5pPr>
-    <a:lvl6pPr marL="2286000" algn="l" defTabSz="457200" rtl="0" eaLnBrk="1" latinLnBrk="0" hangingPunct="1">
-      <a:defRPr sz="1800" kern="1200">
+    <a:lvl6pPr algn="l" defTabSz="457200" eaLnBrk="1" hangingPunct="1" latinLnBrk="0" marL="2286000" rtl="0">
+      <a:defRPr kern="1200" sz="1800">
         <a:solidFill>
           <a:schemeClr val="tx1"/>
         </a:solidFill>
@@ -84,8 +85,8 @@
         <a:cs typeface="+mn-cs"/>
       </a:defRPr>
     </a:lvl6pPr>
-    <a:lvl7pPr marL="2743200" algn="l" defTabSz="457200" rtl="0" eaLnBrk="1" latinLnBrk="0" hangingPunct="1">
-      <a:defRPr sz="1800" kern="1200">
+    <a:lvl7pPr algn="l" defTabSz="457200" eaLnBrk="1" hangingPunct="1" latinLnBrk="0" marL="2743200" rtl="0">
+      <a:defRPr kern="1200" sz="1800">
         <a:solidFill>
           <a:schemeClr val="tx1"/>
         </a:solidFill>
@@ -94,8 +95,8 @@
         <a:cs typeface="+mn-cs"/>
       </a:defRPr>
     </a:lvl7pPr>
-    <a:lvl8pPr marL="3200400" algn="l" defTabSz="457200" rtl="0" eaLnBrk="1" latinLnBrk="0" hangingPunct="1">
-      <a:defRPr sz="1800" kern="1200">
+    <a:lvl8pPr algn="l" defTabSz="457200" eaLnBrk="1" hangingPunct="1" latinLnBrk="0" marL="3200400" rtl="0">
+      <a:defRPr kern="1200" sz="1800">
         <a:solidFill>
           <a:schemeClr val="tx1"/>
         </a:solidFill>
@@ -104,8 +105,8 @@
         <a:cs typeface="+mn-cs"/>
       </a:defRPr>
     </a:lvl8pPr>
-    <a:lvl9pPr marL="3657600" algn="l" defTabSz="457200" rtl="0" eaLnBrk="1" latinLnBrk="0" hangingPunct="1">
-      <a:defRPr sz="1800" kern="1200">
+    <a:lvl9pPr algn="l" defTabSz="457200" eaLnBrk="1" hangingPunct="1" latinLnBrk="0" marL="3657600" rtl="0">
+      <a:defRPr kern="1200" sz="1800">
         <a:solidFill>
           <a:schemeClr val="tx1"/>
         </a:solidFill>
@@ -115,6 +116,22 @@
       </a:defRPr>
     </a:lvl9pPr>
   </p:defaultTextStyle>
+  <p:extLst>
+    <p:ext uri="{EFAFB233-063F-42B5-8137-9DF3F51BA10A}">
+      <p15:sldGuideLst xmlns:p15="http://schemas.microsoft.com/office/powerpoint/2012/main">
+        <p15:guide id="1" orient="horz" pos="1620" userDrawn="1">
+          <p15:clr>
+            <a:srgbClr val="A4A3A4"/>
+          </p15:clr>
+        </p15:guide>
+        <p15:guide id="2" pos="2880" userDrawn="1">
+          <p15:clr>
+            <a:srgbClr val="A4A3A4"/>
+          </p15:clr>
+        </p15:guide>
+      </p15:sldGuideLst>
+    </p:ext>
+  </p:extLst>
 </p:presentation>
 </file>
 
@@ -147,8 +164,8 @@
         </p:nvSpPr>
         <p:spPr>
           <a:xfrm>
-            <a:off x="685800" y="2130425"/>
-            <a:ext cx="7772400" cy="1470025"/>
+            <a:off x="685800" y="1597819"/>
+            <a:ext cx="7772400" cy="1102519"/>
           </a:xfrm>
         </p:spPr>
         <p:txBody>
@@ -156,10 +173,9 @@
           <a:lstStyle/>
           <a:p>
             <a:r>
-              <a:rPr lang="en-US" smtClean="0"/>
+              <a:rPr lang="en-US"/>
               <a:t>Click to edit Master title style</a:t>
             </a:r>
-            <a:endParaRPr lang="en-US"/>
           </a:p>
         </p:txBody>
       </p:sp>
@@ -175,8 +191,8 @@
         </p:nvSpPr>
         <p:spPr>
           <a:xfrm>
-            <a:off x="1371600" y="3886200"/>
-            <a:ext cx="6400800" cy="1752600"/>
+            <a:off x="1371600" y="2914650"/>
+            <a:ext cx="6400800" cy="1314450"/>
           </a:xfrm>
         </p:spPr>
         <p:txBody>
@@ -192,7 +208,7 @@
                 </a:solidFill>
               </a:defRPr>
             </a:lvl1pPr>
-            <a:lvl2pPr marL="457200" indent="0" algn="ctr">
+            <a:lvl2pPr marL="342900" indent="0" algn="ctr">
               <a:buNone/>
               <a:defRPr>
                 <a:solidFill>
@@ -202,7 +218,7 @@
                 </a:solidFill>
               </a:defRPr>
             </a:lvl2pPr>
-            <a:lvl3pPr marL="914400" indent="0" algn="ctr">
+            <a:lvl3pPr marL="685800" indent="0" algn="ctr">
               <a:buNone/>
               <a:defRPr>
                 <a:solidFill>
@@ -212,7 +228,7 @@
                 </a:solidFill>
               </a:defRPr>
             </a:lvl3pPr>
-            <a:lvl4pPr marL="1371600" indent="0" algn="ctr">
+            <a:lvl4pPr marL="1028700" indent="0" algn="ctr">
               <a:buNone/>
               <a:defRPr>
                 <a:solidFill>
@@ -222,7 +238,7 @@
                 </a:solidFill>
               </a:defRPr>
             </a:lvl4pPr>
-            <a:lvl5pPr marL="1828800" indent="0" algn="ctr">
+            <a:lvl5pPr marL="1371600" indent="0" algn="ctr">
               <a:buNone/>
               <a:defRPr>
                 <a:solidFill>
@@ -232,7 +248,7 @@
                 </a:solidFill>
               </a:defRPr>
             </a:lvl5pPr>
-            <a:lvl6pPr marL="2286000" indent="0" algn="ctr">
+            <a:lvl6pPr marL="1714500" indent="0" algn="ctr">
               <a:buNone/>
               <a:defRPr>
                 <a:solidFill>
@@ -242,7 +258,7 @@
                 </a:solidFill>
               </a:defRPr>
             </a:lvl6pPr>
-            <a:lvl7pPr marL="2743200" indent="0" algn="ctr">
+            <a:lvl7pPr marL="2057400" indent="0" algn="ctr">
               <a:buNone/>
               <a:defRPr>
                 <a:solidFill>
@@ -252,7 +268,7 @@
                 </a:solidFill>
               </a:defRPr>
             </a:lvl7pPr>
-            <a:lvl8pPr marL="3200400" indent="0" algn="ctr">
+            <a:lvl8pPr marL="2400300" indent="0" algn="ctr">
               <a:buNone/>
               <a:defRPr>
                 <a:solidFill>
@@ -262,7 +278,7 @@
                 </a:solidFill>
               </a:defRPr>
             </a:lvl8pPr>
-            <a:lvl9pPr marL="3657600" indent="0" algn="ctr">
+            <a:lvl9pPr marL="2743200" indent="0" algn="ctr">
               <a:buNone/>
               <a:defRPr>
                 <a:solidFill>
@@ -275,31 +291,30 @@
           </a:lstStyle>
           <a:p>
             <a:r>
+              <a:rPr lang="en-US"/>
+              <a:t>Click to edit Master subtitle style</a:t>
+            </a:r>
+          </a:p>
+        </p:txBody>
+      </p:sp>
+      <p:sp>
+        <p:nvSpPr>
+          <p:cNvPr id="4" name="Date Placeholder 3"/>
+          <p:cNvSpPr>
+            <a:spLocks noGrp="1"/>
+          </p:cNvSpPr>
+          <p:nvPr>
+            <p:ph type="dt" sz="half" idx="10"/>
+          </p:nvPr>
+        </p:nvSpPr>
+        <p:spPr/>
+        <p:txBody>
+          <a:bodyPr/>
+          <a:lstStyle/>
+          <a:p>
+            <a:fld id="{241EB5C9-1307-BA42-ABA2-0BC069CD8E7F}" type="datetimeFigureOut">
               <a:rPr lang="en-US" smtClean="0"/>
-              <a:t>Click to edit Master subtitle style</a:t>
-            </a:r>
-            <a:endParaRPr lang="en-US"/>
-          </a:p>
-        </p:txBody>
-      </p:sp>
-      <p:sp>
-        <p:nvSpPr>
-          <p:cNvPr id="4" name="Date Placeholder 3"/>
-          <p:cNvSpPr>
-            <a:spLocks noGrp="1"/>
-          </p:cNvSpPr>
-          <p:nvPr>
-            <p:ph type="dt" sz="half" idx="10"/>
-          </p:nvPr>
-        </p:nvSpPr>
-        <p:spPr/>
-        <p:txBody>
-          <a:bodyPr/>
-          <a:lstStyle/>
-          <a:p>
-            <a:fld id="{5BCAD085-E8A6-8845-BD4E-CB4CCA059FC4}" type="datetimeFigureOut">
-              <a:rPr lang="en-US" smtClean="0"/>
-              <a:t>1/27/13</a:t>
+              <a:t>1/2/22</a:t>
             </a:fld>
             <a:endParaRPr lang="en-US"/>
           </a:p>
@@ -339,7 +354,7 @@
           <a:bodyPr/>
           <a:lstStyle/>
           <a:p>
-            <a:fld id="{C1FF6DA9-008F-8B48-92A6-B652298478BF}" type="slidenum">
+            <a:fld id="{C5EF2332-01BF-834F-8236-50238282D533}" type="slidenum">
               <a:rPr lang="en-US" smtClean="0"/>
               <a:t>‹#›</a:t>
             </a:fld>
@@ -350,7 +365,7 @@
     </p:spTree>
     <p:extLst>
       <p:ext uri="{BB962C8B-B14F-4D97-AF65-F5344CB8AC3E}">
-        <p14:creationId xmlns:p14="http://schemas.microsoft.com/office/powerpoint/2010/main" val="3168075583"/>
+        <p14:creationId xmlns:p14="http://schemas.microsoft.com/office/powerpoint/2010/main" val="1444357513"/>
       </p:ext>
     </p:extLst>
   </p:cSld>
@@ -393,83 +408,81 @@
           <a:lstStyle/>
           <a:p>
             <a:r>
+              <a:rPr lang="en-US"/>
+              <a:t>Click to edit Master title style</a:t>
+            </a:r>
+          </a:p>
+        </p:txBody>
+      </p:sp>
+      <p:sp>
+        <p:nvSpPr>
+          <p:cNvPr id="3" name="Vertical Text Placeholder 2"/>
+          <p:cNvSpPr>
+            <a:spLocks noGrp="1"/>
+          </p:cNvSpPr>
+          <p:nvPr>
+            <p:ph type="body" orient="vert" idx="1"/>
+          </p:nvPr>
+        </p:nvSpPr>
+        <p:spPr/>
+        <p:txBody>
+          <a:bodyPr vert="eaVert"/>
+          <a:lstStyle/>
+          <a:p>
+            <a:pPr lvl="0"/>
+            <a:r>
+              <a:rPr lang="en-US"/>
+              <a:t>Click to edit Master text styles</a:t>
+            </a:r>
+          </a:p>
+          <a:p>
+            <a:pPr lvl="1"/>
+            <a:r>
+              <a:rPr lang="en-US"/>
+              <a:t>Second level</a:t>
+            </a:r>
+          </a:p>
+          <a:p>
+            <a:pPr lvl="2"/>
+            <a:r>
+              <a:rPr lang="en-US"/>
+              <a:t>Third level</a:t>
+            </a:r>
+          </a:p>
+          <a:p>
+            <a:pPr lvl="3"/>
+            <a:r>
+              <a:rPr lang="en-US"/>
+              <a:t>Fourth level</a:t>
+            </a:r>
+          </a:p>
+          <a:p>
+            <a:pPr lvl="4"/>
+            <a:r>
+              <a:rPr lang="en-US"/>
+              <a:t>Fifth level</a:t>
+            </a:r>
+          </a:p>
+        </p:txBody>
+      </p:sp>
+      <p:sp>
+        <p:nvSpPr>
+          <p:cNvPr id="4" name="Date Placeholder 3"/>
+          <p:cNvSpPr>
+            <a:spLocks noGrp="1"/>
+          </p:cNvSpPr>
+          <p:nvPr>
+            <p:ph type="dt" sz="half" idx="10"/>
+          </p:nvPr>
+        </p:nvSpPr>
+        <p:spPr/>
+        <p:txBody>
+          <a:bodyPr/>
+          <a:lstStyle/>
+          <a:p>
+            <a:fld id="{241EB5C9-1307-BA42-ABA2-0BC069CD8E7F}" type="datetimeFigureOut">
               <a:rPr lang="en-US" smtClean="0"/>
-              <a:t>Click to edit Master title style</a:t>
-            </a:r>
-            <a:endParaRPr lang="en-US"/>
-          </a:p>
-        </p:txBody>
-      </p:sp>
-      <p:sp>
-        <p:nvSpPr>
-          <p:cNvPr id="3" name="Vertical Text Placeholder 2"/>
-          <p:cNvSpPr>
-            <a:spLocks noGrp="1"/>
-          </p:cNvSpPr>
-          <p:nvPr>
-            <p:ph type="body" orient="vert" idx="1"/>
-          </p:nvPr>
-        </p:nvSpPr>
-        <p:spPr/>
-        <p:txBody>
-          <a:bodyPr vert="eaVert"/>
-          <a:lstStyle/>
-          <a:p>
-            <a:pPr lvl="0"/>
-            <a:r>
-              <a:rPr lang="en-US" smtClean="0"/>
-              <a:t>Click to edit Master text styles</a:t>
-            </a:r>
-          </a:p>
-          <a:p>
-            <a:pPr lvl="1"/>
-            <a:r>
-              <a:rPr lang="en-US" smtClean="0"/>
-              <a:t>Second level</a:t>
-            </a:r>
-          </a:p>
-          <a:p>
-            <a:pPr lvl="2"/>
-            <a:r>
-              <a:rPr lang="en-US" smtClean="0"/>
-              <a:t>Third level</a:t>
-            </a:r>
-          </a:p>
-          <a:p>
-            <a:pPr lvl="3"/>
-            <a:r>
-              <a:rPr lang="en-US" smtClean="0"/>
-              <a:t>Fourth level</a:t>
-            </a:r>
-          </a:p>
-          <a:p>
-            <a:pPr lvl="4"/>
-            <a:r>
-              <a:rPr lang="en-US" smtClean="0"/>
-              <a:t>Fifth level</a:t>
-            </a:r>
-            <a:endParaRPr lang="en-US"/>
-          </a:p>
-        </p:txBody>
-      </p:sp>
-      <p:sp>
-        <p:nvSpPr>
-          <p:cNvPr id="4" name="Date Placeholder 3"/>
-          <p:cNvSpPr>
-            <a:spLocks noGrp="1"/>
-          </p:cNvSpPr>
-          <p:nvPr>
-            <p:ph type="dt" sz="half" idx="10"/>
-          </p:nvPr>
-        </p:nvSpPr>
-        <p:spPr/>
-        <p:txBody>
-          <a:bodyPr/>
-          <a:lstStyle/>
-          <a:p>
-            <a:fld id="{5BCAD085-E8A6-8845-BD4E-CB4CCA059FC4}" type="datetimeFigureOut">
-              <a:rPr lang="en-US" smtClean="0"/>
-              <a:t>1/27/13</a:t>
+              <a:t>1/2/22</a:t>
             </a:fld>
             <a:endParaRPr lang="en-US"/>
           </a:p>
@@ -509,7 +522,7 @@
           <a:bodyPr/>
           <a:lstStyle/>
           <a:p>
-            <a:fld id="{C1FF6DA9-008F-8B48-92A6-B652298478BF}" type="slidenum">
+            <a:fld id="{C5EF2332-01BF-834F-8236-50238282D533}" type="slidenum">
               <a:rPr lang="en-US" smtClean="0"/>
               <a:t>‹#›</a:t>
             </a:fld>
@@ -520,7 +533,7 @@
     </p:spTree>
     <p:extLst>
       <p:ext uri="{BB962C8B-B14F-4D97-AF65-F5344CB8AC3E}">
-        <p14:creationId xmlns:p14="http://schemas.microsoft.com/office/powerpoint/2010/main" val="2910927964"/>
+        <p14:creationId xmlns:p14="http://schemas.microsoft.com/office/powerpoint/2010/main" val="313914798"/>
       </p:ext>
     </p:extLst>
   </p:cSld>
@@ -559,8 +572,8 @@
         </p:nvSpPr>
         <p:spPr>
           <a:xfrm>
-            <a:off x="6629400" y="274638"/>
-            <a:ext cx="2057400" cy="5851525"/>
+            <a:off x="6629400" y="205979"/>
+            <a:ext cx="2057400" cy="4388644"/>
           </a:xfrm>
         </p:spPr>
         <p:txBody>
@@ -568,10 +581,9 @@
           <a:lstStyle/>
           <a:p>
             <a:r>
-              <a:rPr lang="en-US" smtClean="0"/>
+              <a:rPr lang="en-US"/>
               <a:t>Click to edit Master title style</a:t>
             </a:r>
-            <a:endParaRPr lang="en-US"/>
           </a:p>
         </p:txBody>
       </p:sp>
@@ -587,8 +599,8 @@
         </p:nvSpPr>
         <p:spPr>
           <a:xfrm>
-            <a:off x="457200" y="274638"/>
-            <a:ext cx="6019800" cy="5851525"/>
+            <a:off x="457200" y="205979"/>
+            <a:ext cx="6019800" cy="4388644"/>
           </a:xfrm>
         </p:spPr>
         <p:txBody>
@@ -597,59 +609,58 @@
           <a:p>
             <a:pPr lvl="0"/>
             <a:r>
+              <a:rPr lang="en-US"/>
+              <a:t>Click to edit Master text styles</a:t>
+            </a:r>
+          </a:p>
+          <a:p>
+            <a:pPr lvl="1"/>
+            <a:r>
+              <a:rPr lang="en-US"/>
+              <a:t>Second level</a:t>
+            </a:r>
+          </a:p>
+          <a:p>
+            <a:pPr lvl="2"/>
+            <a:r>
+              <a:rPr lang="en-US"/>
+              <a:t>Third level</a:t>
+            </a:r>
+          </a:p>
+          <a:p>
+            <a:pPr lvl="3"/>
+            <a:r>
+              <a:rPr lang="en-US"/>
+              <a:t>Fourth level</a:t>
+            </a:r>
+          </a:p>
+          <a:p>
+            <a:pPr lvl="4"/>
+            <a:r>
+              <a:rPr lang="en-US"/>
+              <a:t>Fifth level</a:t>
+            </a:r>
+          </a:p>
+        </p:txBody>
+      </p:sp>
+      <p:sp>
+        <p:nvSpPr>
+          <p:cNvPr id="4" name="Date Placeholder 3"/>
+          <p:cNvSpPr>
+            <a:spLocks noGrp="1"/>
+          </p:cNvSpPr>
+          <p:nvPr>
+            <p:ph type="dt" sz="half" idx="10"/>
+          </p:nvPr>
+        </p:nvSpPr>
+        <p:spPr/>
+        <p:txBody>
+          <a:bodyPr/>
+          <a:lstStyle/>
+          <a:p>
+            <a:fld id="{241EB5C9-1307-BA42-ABA2-0BC069CD8E7F}" type="datetimeFigureOut">
               <a:rPr lang="en-US" smtClean="0"/>
-              <a:t>Click to edit Master text styles</a:t>
-            </a:r>
-          </a:p>
-          <a:p>
-            <a:pPr lvl="1"/>
-            <a:r>
-              <a:rPr lang="en-US" smtClean="0"/>
-              <a:t>Second level</a:t>
-            </a:r>
-          </a:p>
-          <a:p>
-            <a:pPr lvl="2"/>
-            <a:r>
-              <a:rPr lang="en-US" smtClean="0"/>
-              <a:t>Third level</a:t>
-            </a:r>
-          </a:p>
-          <a:p>
-            <a:pPr lvl="3"/>
-            <a:r>
-              <a:rPr lang="en-US" smtClean="0"/>
-              <a:t>Fourth level</a:t>
-            </a:r>
-          </a:p>
-          <a:p>
-            <a:pPr lvl="4"/>
-            <a:r>
-              <a:rPr lang="en-US" smtClean="0"/>
-              <a:t>Fifth level</a:t>
-            </a:r>
-            <a:endParaRPr lang="en-US"/>
-          </a:p>
-        </p:txBody>
-      </p:sp>
-      <p:sp>
-        <p:nvSpPr>
-          <p:cNvPr id="4" name="Date Placeholder 3"/>
-          <p:cNvSpPr>
-            <a:spLocks noGrp="1"/>
-          </p:cNvSpPr>
-          <p:nvPr>
-            <p:ph type="dt" sz="half" idx="10"/>
-          </p:nvPr>
-        </p:nvSpPr>
-        <p:spPr/>
-        <p:txBody>
-          <a:bodyPr/>
-          <a:lstStyle/>
-          <a:p>
-            <a:fld id="{5BCAD085-E8A6-8845-BD4E-CB4CCA059FC4}" type="datetimeFigureOut">
-              <a:rPr lang="en-US" smtClean="0"/>
-              <a:t>1/27/13</a:t>
+              <a:t>1/2/22</a:t>
             </a:fld>
             <a:endParaRPr lang="en-US"/>
           </a:p>
@@ -689,7 +700,7 @@
           <a:bodyPr/>
           <a:lstStyle/>
           <a:p>
-            <a:fld id="{C1FF6DA9-008F-8B48-92A6-B652298478BF}" type="slidenum">
+            <a:fld id="{C5EF2332-01BF-834F-8236-50238282D533}" type="slidenum">
               <a:rPr lang="en-US" smtClean="0"/>
               <a:t>‹#›</a:t>
             </a:fld>
@@ -700,7 +711,7 @@
     </p:spTree>
     <p:extLst>
       <p:ext uri="{BB962C8B-B14F-4D97-AF65-F5344CB8AC3E}">
-        <p14:creationId xmlns:p14="http://schemas.microsoft.com/office/powerpoint/2010/main" val="3612223792"/>
+        <p14:creationId xmlns:p14="http://schemas.microsoft.com/office/powerpoint/2010/main" val="2581529045"/>
       </p:ext>
     </p:extLst>
   </p:cSld>
@@ -743,83 +754,81 @@
           <a:lstStyle/>
           <a:p>
             <a:r>
+              <a:rPr lang="en-US"/>
+              <a:t>Click to edit Master title style</a:t>
+            </a:r>
+          </a:p>
+        </p:txBody>
+      </p:sp>
+      <p:sp>
+        <p:nvSpPr>
+          <p:cNvPr id="3" name="Content Placeholder 2"/>
+          <p:cNvSpPr>
+            <a:spLocks noGrp="1"/>
+          </p:cNvSpPr>
+          <p:nvPr>
+            <p:ph idx="1"/>
+          </p:nvPr>
+        </p:nvSpPr>
+        <p:spPr/>
+        <p:txBody>
+          <a:bodyPr/>
+          <a:lstStyle/>
+          <a:p>
+            <a:pPr lvl="0"/>
+            <a:r>
+              <a:rPr lang="en-US"/>
+              <a:t>Click to edit Master text styles</a:t>
+            </a:r>
+          </a:p>
+          <a:p>
+            <a:pPr lvl="1"/>
+            <a:r>
+              <a:rPr lang="en-US"/>
+              <a:t>Second level</a:t>
+            </a:r>
+          </a:p>
+          <a:p>
+            <a:pPr lvl="2"/>
+            <a:r>
+              <a:rPr lang="en-US"/>
+              <a:t>Third level</a:t>
+            </a:r>
+          </a:p>
+          <a:p>
+            <a:pPr lvl="3"/>
+            <a:r>
+              <a:rPr lang="en-US"/>
+              <a:t>Fourth level</a:t>
+            </a:r>
+          </a:p>
+          <a:p>
+            <a:pPr lvl="4"/>
+            <a:r>
+              <a:rPr lang="en-US"/>
+              <a:t>Fifth level</a:t>
+            </a:r>
+          </a:p>
+        </p:txBody>
+      </p:sp>
+      <p:sp>
+        <p:nvSpPr>
+          <p:cNvPr id="4" name="Date Placeholder 3"/>
+          <p:cNvSpPr>
+            <a:spLocks noGrp="1"/>
+          </p:cNvSpPr>
+          <p:nvPr>
+            <p:ph type="dt" sz="half" idx="10"/>
+          </p:nvPr>
+        </p:nvSpPr>
+        <p:spPr/>
+        <p:txBody>
+          <a:bodyPr/>
+          <a:lstStyle/>
+          <a:p>
+            <a:fld id="{241EB5C9-1307-BA42-ABA2-0BC069CD8E7F}" type="datetimeFigureOut">
               <a:rPr lang="en-US" smtClean="0"/>
-              <a:t>Click to edit Master title style</a:t>
-            </a:r>
-            <a:endParaRPr lang="en-US"/>
-          </a:p>
-        </p:txBody>
-      </p:sp>
-      <p:sp>
-        <p:nvSpPr>
-          <p:cNvPr id="3" name="Content Placeholder 2"/>
-          <p:cNvSpPr>
-            <a:spLocks noGrp="1"/>
-          </p:cNvSpPr>
-          <p:nvPr>
-            <p:ph idx="1"/>
-          </p:nvPr>
-        </p:nvSpPr>
-        <p:spPr/>
-        <p:txBody>
-          <a:bodyPr/>
-          <a:lstStyle/>
-          <a:p>
-            <a:pPr lvl="0"/>
-            <a:r>
-              <a:rPr lang="en-US" smtClean="0"/>
-              <a:t>Click to edit Master text styles</a:t>
-            </a:r>
-          </a:p>
-          <a:p>
-            <a:pPr lvl="1"/>
-            <a:r>
-              <a:rPr lang="en-US" smtClean="0"/>
-              <a:t>Second level</a:t>
-            </a:r>
-          </a:p>
-          <a:p>
-            <a:pPr lvl="2"/>
-            <a:r>
-              <a:rPr lang="en-US" smtClean="0"/>
-              <a:t>Third level</a:t>
-            </a:r>
-          </a:p>
-          <a:p>
-            <a:pPr lvl="3"/>
-            <a:r>
-              <a:rPr lang="en-US" smtClean="0"/>
-              <a:t>Fourth level</a:t>
-            </a:r>
-          </a:p>
-          <a:p>
-            <a:pPr lvl="4"/>
-            <a:r>
-              <a:rPr lang="en-US" smtClean="0"/>
-              <a:t>Fifth level</a:t>
-            </a:r>
-            <a:endParaRPr lang="en-US"/>
-          </a:p>
-        </p:txBody>
-      </p:sp>
-      <p:sp>
-        <p:nvSpPr>
-          <p:cNvPr id="4" name="Date Placeholder 3"/>
-          <p:cNvSpPr>
-            <a:spLocks noGrp="1"/>
-          </p:cNvSpPr>
-          <p:nvPr>
-            <p:ph type="dt" sz="half" idx="10"/>
-          </p:nvPr>
-        </p:nvSpPr>
-        <p:spPr/>
-        <p:txBody>
-          <a:bodyPr/>
-          <a:lstStyle/>
-          <a:p>
-            <a:fld id="{5BCAD085-E8A6-8845-BD4E-CB4CCA059FC4}" type="datetimeFigureOut">
-              <a:rPr lang="en-US" smtClean="0"/>
-              <a:t>1/27/13</a:t>
+              <a:t>1/2/22</a:t>
             </a:fld>
             <a:endParaRPr lang="en-US"/>
           </a:p>
@@ -859,7 +868,7 @@
           <a:bodyPr/>
           <a:lstStyle/>
           <a:p>
-            <a:fld id="{C1FF6DA9-008F-8B48-92A6-B652298478BF}" type="slidenum">
+            <a:fld id="{C5EF2332-01BF-834F-8236-50238282D533}" type="slidenum">
               <a:rPr lang="en-US" smtClean="0"/>
               <a:t>‹#›</a:t>
             </a:fld>
@@ -870,7 +879,7 @@
     </p:spTree>
     <p:extLst>
       <p:ext uri="{BB962C8B-B14F-4D97-AF65-F5344CB8AC3E}">
-        <p14:creationId xmlns:p14="http://schemas.microsoft.com/office/powerpoint/2010/main" val="2614314258"/>
+        <p14:creationId xmlns:p14="http://schemas.microsoft.com/office/powerpoint/2010/main" val="338346009"/>
       </p:ext>
     </p:extLst>
   </p:cSld>
@@ -909,23 +918,22 @@
         </p:nvSpPr>
         <p:spPr>
           <a:xfrm>
-            <a:off x="722313" y="4406900"/>
-            <a:ext cx="7772400" cy="1362075"/>
+            <a:off x="722313" y="3305176"/>
+            <a:ext cx="7772400" cy="1021556"/>
           </a:xfrm>
         </p:spPr>
         <p:txBody>
           <a:bodyPr anchor="t"/>
           <a:lstStyle>
             <a:lvl1pPr algn="l">
-              <a:defRPr sz="4000" b="1" cap="all"/>
+              <a:defRPr sz="3000" b="1" cap="all"/>
             </a:lvl1pPr>
           </a:lstStyle>
           <a:p>
             <a:r>
-              <a:rPr lang="en-US" smtClean="0"/>
+              <a:rPr lang="en-US"/>
               <a:t>Click to edit Master title style</a:t>
             </a:r>
-            <a:endParaRPr lang="en-US"/>
           </a:p>
         </p:txBody>
       </p:sp>
@@ -941,8 +949,8 @@
         </p:nvSpPr>
         <p:spPr>
           <a:xfrm>
-            <a:off x="722313" y="2906713"/>
-            <a:ext cx="7772400" cy="1500187"/>
+            <a:off x="722313" y="2180035"/>
+            <a:ext cx="7772400" cy="1125140"/>
           </a:xfrm>
         </p:spPr>
         <p:txBody>
@@ -950,7 +958,7 @@
           <a:lstStyle>
             <a:lvl1pPr marL="0" indent="0">
               <a:buNone/>
-              <a:defRPr sz="2000">
+              <a:defRPr sz="1500">
                 <a:solidFill>
                   <a:schemeClr val="tx1">
                     <a:tint val="75000"/>
@@ -958,9 +966,9 @@
                 </a:solidFill>
               </a:defRPr>
             </a:lvl1pPr>
-            <a:lvl2pPr marL="457200" indent="0">
-              <a:buNone/>
-              <a:defRPr sz="1800">
+            <a:lvl2pPr marL="342900" indent="0">
+              <a:buNone/>
+              <a:defRPr sz="1350">
                 <a:solidFill>
                   <a:schemeClr val="tx1">
                     <a:tint val="75000"/>
@@ -968,9 +976,9 @@
                 </a:solidFill>
               </a:defRPr>
             </a:lvl2pPr>
-            <a:lvl3pPr marL="914400" indent="0">
-              <a:buNone/>
-              <a:defRPr sz="1600">
+            <a:lvl3pPr marL="685800" indent="0">
+              <a:buNone/>
+              <a:defRPr sz="1200">
                 <a:solidFill>
                   <a:schemeClr val="tx1">
                     <a:tint val="75000"/>
@@ -978,9 +986,9 @@
                 </a:solidFill>
               </a:defRPr>
             </a:lvl3pPr>
-            <a:lvl4pPr marL="1371600" indent="0">
-              <a:buNone/>
-              <a:defRPr sz="1400">
+            <a:lvl4pPr marL="1028700" indent="0">
+              <a:buNone/>
+              <a:defRPr sz="1050">
                 <a:solidFill>
                   <a:schemeClr val="tx1">
                     <a:tint val="75000"/>
@@ -988,9 +996,9 @@
                 </a:solidFill>
               </a:defRPr>
             </a:lvl4pPr>
-            <a:lvl5pPr marL="1828800" indent="0">
-              <a:buNone/>
-              <a:defRPr sz="1400">
+            <a:lvl5pPr marL="1371600" indent="0">
+              <a:buNone/>
+              <a:defRPr sz="1050">
                 <a:solidFill>
                   <a:schemeClr val="tx1">
                     <a:tint val="75000"/>
@@ -998,9 +1006,9 @@
                 </a:solidFill>
               </a:defRPr>
             </a:lvl5pPr>
-            <a:lvl6pPr marL="2286000" indent="0">
-              <a:buNone/>
-              <a:defRPr sz="1400">
+            <a:lvl6pPr marL="1714500" indent="0">
+              <a:buNone/>
+              <a:defRPr sz="1050">
                 <a:solidFill>
                   <a:schemeClr val="tx1">
                     <a:tint val="75000"/>
@@ -1008,9 +1016,9 @@
                 </a:solidFill>
               </a:defRPr>
             </a:lvl6pPr>
-            <a:lvl7pPr marL="2743200" indent="0">
-              <a:buNone/>
-              <a:defRPr sz="1400">
+            <a:lvl7pPr marL="2057400" indent="0">
+              <a:buNone/>
+              <a:defRPr sz="1050">
                 <a:solidFill>
                   <a:schemeClr val="tx1">
                     <a:tint val="75000"/>
@@ -1018,9 +1026,9 @@
                 </a:solidFill>
               </a:defRPr>
             </a:lvl7pPr>
-            <a:lvl8pPr marL="3200400" indent="0">
-              <a:buNone/>
-              <a:defRPr sz="1400">
+            <a:lvl8pPr marL="2400300" indent="0">
+              <a:buNone/>
+              <a:defRPr sz="1050">
                 <a:solidFill>
                   <a:schemeClr val="tx1">
                     <a:tint val="75000"/>
@@ -1028,9 +1036,9 @@
                 </a:solidFill>
               </a:defRPr>
             </a:lvl8pPr>
-            <a:lvl9pPr marL="3657600" indent="0">
-              <a:buNone/>
-              <a:defRPr sz="1400">
+            <a:lvl9pPr marL="2743200" indent="0">
+              <a:buNone/>
+              <a:defRPr sz="1050">
                 <a:solidFill>
                   <a:schemeClr val="tx1">
                     <a:tint val="75000"/>
@@ -1042,30 +1050,30 @@
           <a:p>
             <a:pPr lvl="0"/>
             <a:r>
+              <a:rPr lang="en-US"/>
+              <a:t>Click to edit Master text styles</a:t>
+            </a:r>
+          </a:p>
+        </p:txBody>
+      </p:sp>
+      <p:sp>
+        <p:nvSpPr>
+          <p:cNvPr id="4" name="Date Placeholder 3"/>
+          <p:cNvSpPr>
+            <a:spLocks noGrp="1"/>
+          </p:cNvSpPr>
+          <p:nvPr>
+            <p:ph type="dt" sz="half" idx="10"/>
+          </p:nvPr>
+        </p:nvSpPr>
+        <p:spPr/>
+        <p:txBody>
+          <a:bodyPr/>
+          <a:lstStyle/>
+          <a:p>
+            <a:fld id="{241EB5C9-1307-BA42-ABA2-0BC069CD8E7F}" type="datetimeFigureOut">
               <a:rPr lang="en-US" smtClean="0"/>
-              <a:t>Click to edit Master text styles</a:t>
-            </a:r>
-          </a:p>
-        </p:txBody>
-      </p:sp>
-      <p:sp>
-        <p:nvSpPr>
-          <p:cNvPr id="4" name="Date Placeholder 3"/>
-          <p:cNvSpPr>
-            <a:spLocks noGrp="1"/>
-          </p:cNvSpPr>
-          <p:nvPr>
-            <p:ph type="dt" sz="half" idx="10"/>
-          </p:nvPr>
-        </p:nvSpPr>
-        <p:spPr/>
-        <p:txBody>
-          <a:bodyPr/>
-          <a:lstStyle/>
-          <a:p>
-            <a:fld id="{5BCAD085-E8A6-8845-BD4E-CB4CCA059FC4}" type="datetimeFigureOut">
-              <a:rPr lang="en-US" smtClean="0"/>
-              <a:t>1/27/13</a:t>
+              <a:t>1/2/22</a:t>
             </a:fld>
             <a:endParaRPr lang="en-US"/>
           </a:p>
@@ -1105,7 +1113,7 @@
           <a:bodyPr/>
           <a:lstStyle/>
           <a:p>
-            <a:fld id="{C1FF6DA9-008F-8B48-92A6-B652298478BF}" type="slidenum">
+            <a:fld id="{C5EF2332-01BF-834F-8236-50238282D533}" type="slidenum">
               <a:rPr lang="en-US" smtClean="0"/>
               <a:t>‹#›</a:t>
             </a:fld>
@@ -1116,7 +1124,7 @@
     </p:spTree>
     <p:extLst>
       <p:ext uri="{BB962C8B-B14F-4D97-AF65-F5344CB8AC3E}">
-        <p14:creationId xmlns:p14="http://schemas.microsoft.com/office/powerpoint/2010/main" val="960648375"/>
+        <p14:creationId xmlns:p14="http://schemas.microsoft.com/office/powerpoint/2010/main" val="1073069076"/>
       </p:ext>
     </p:extLst>
   </p:cSld>
@@ -1159,10 +1167,9 @@
           <a:lstStyle/>
           <a:p>
             <a:r>
-              <a:rPr lang="en-US" smtClean="0"/>
+              <a:rPr lang="en-US"/>
               <a:t>Click to edit Master title style</a:t>
             </a:r>
-            <a:endParaRPr lang="en-US"/>
           </a:p>
         </p:txBody>
       </p:sp>
@@ -1178,76 +1185,75 @@
         </p:nvSpPr>
         <p:spPr>
           <a:xfrm>
-            <a:off x="457200" y="1600200"/>
-            <a:ext cx="4038600" cy="4525963"/>
+            <a:off x="457200" y="1200151"/>
+            <a:ext cx="4038600" cy="3394472"/>
           </a:xfrm>
         </p:spPr>
         <p:txBody>
           <a:bodyPr/>
           <a:lstStyle>
             <a:lvl1pPr>
-              <a:defRPr sz="2800"/>
+              <a:defRPr sz="2100"/>
             </a:lvl1pPr>
             <a:lvl2pPr>
-              <a:defRPr sz="2400"/>
+              <a:defRPr sz="1800"/>
             </a:lvl2pPr>
             <a:lvl3pPr>
-              <a:defRPr sz="2000"/>
+              <a:defRPr sz="1500"/>
             </a:lvl3pPr>
             <a:lvl4pPr>
-              <a:defRPr sz="1800"/>
+              <a:defRPr sz="1350"/>
             </a:lvl4pPr>
             <a:lvl5pPr>
-              <a:defRPr sz="1800"/>
+              <a:defRPr sz="1350"/>
             </a:lvl5pPr>
             <a:lvl6pPr>
-              <a:defRPr sz="1800"/>
+              <a:defRPr sz="1350"/>
             </a:lvl6pPr>
             <a:lvl7pPr>
-              <a:defRPr sz="1800"/>
+              <a:defRPr sz="1350"/>
             </a:lvl7pPr>
             <a:lvl8pPr>
-              <a:defRPr sz="1800"/>
+              <a:defRPr sz="1350"/>
             </a:lvl8pPr>
             <a:lvl9pPr>
-              <a:defRPr sz="1800"/>
+              <a:defRPr sz="1350"/>
             </a:lvl9pPr>
           </a:lstStyle>
           <a:p>
             <a:pPr lvl="0"/>
             <a:r>
-              <a:rPr lang="en-US" smtClean="0"/>
+              <a:rPr lang="en-US"/>
               <a:t>Click to edit Master text styles</a:t>
             </a:r>
           </a:p>
           <a:p>
             <a:pPr lvl="1"/>
             <a:r>
-              <a:rPr lang="en-US" smtClean="0"/>
+              <a:rPr lang="en-US"/>
               <a:t>Second level</a:t>
             </a:r>
           </a:p>
           <a:p>
             <a:pPr lvl="2"/>
             <a:r>
-              <a:rPr lang="en-US" smtClean="0"/>
+              <a:rPr lang="en-US"/>
               <a:t>Third level</a:t>
             </a:r>
           </a:p>
           <a:p>
             <a:pPr lvl="3"/>
             <a:r>
-              <a:rPr lang="en-US" smtClean="0"/>
+              <a:rPr lang="en-US"/>
               <a:t>Fourth level</a:t>
             </a:r>
           </a:p>
           <a:p>
             <a:pPr lvl="4"/>
             <a:r>
-              <a:rPr lang="en-US" smtClean="0"/>
+              <a:rPr lang="en-US"/>
               <a:t>Fifth level</a:t>
             </a:r>
-            <a:endParaRPr lang="en-US"/>
           </a:p>
         </p:txBody>
       </p:sp>
@@ -1263,97 +1269,96 @@
         </p:nvSpPr>
         <p:spPr>
           <a:xfrm>
-            <a:off x="4648200" y="1600200"/>
-            <a:ext cx="4038600" cy="4525963"/>
+            <a:off x="4648200" y="1200151"/>
+            <a:ext cx="4038600" cy="3394472"/>
           </a:xfrm>
         </p:spPr>
         <p:txBody>
           <a:bodyPr/>
           <a:lstStyle>
             <a:lvl1pPr>
-              <a:defRPr sz="2800"/>
+              <a:defRPr sz="2100"/>
             </a:lvl1pPr>
             <a:lvl2pPr>
-              <a:defRPr sz="2400"/>
+              <a:defRPr sz="1800"/>
             </a:lvl2pPr>
             <a:lvl3pPr>
-              <a:defRPr sz="2000"/>
+              <a:defRPr sz="1500"/>
             </a:lvl3pPr>
             <a:lvl4pPr>
-              <a:defRPr sz="1800"/>
+              <a:defRPr sz="1350"/>
             </a:lvl4pPr>
             <a:lvl5pPr>
-              <a:defRPr sz="1800"/>
+              <a:defRPr sz="1350"/>
             </a:lvl5pPr>
             <a:lvl6pPr>
-              <a:defRPr sz="1800"/>
+              <a:defRPr sz="1350"/>
             </a:lvl6pPr>
             <a:lvl7pPr>
-              <a:defRPr sz="1800"/>
+              <a:defRPr sz="1350"/>
             </a:lvl7pPr>
             <a:lvl8pPr>
-              <a:defRPr sz="1800"/>
+              <a:defRPr sz="1350"/>
             </a:lvl8pPr>
             <a:lvl9pPr>
-              <a:defRPr sz="1800"/>
+              <a:defRPr sz="1350"/>
             </a:lvl9pPr>
           </a:lstStyle>
           <a:p>
             <a:pPr lvl="0"/>
             <a:r>
+              <a:rPr lang="en-US"/>
+              <a:t>Click to edit Master text styles</a:t>
+            </a:r>
+          </a:p>
+          <a:p>
+            <a:pPr lvl="1"/>
+            <a:r>
+              <a:rPr lang="en-US"/>
+              <a:t>Second level</a:t>
+            </a:r>
+          </a:p>
+          <a:p>
+            <a:pPr lvl="2"/>
+            <a:r>
+              <a:rPr lang="en-US"/>
+              <a:t>Third level</a:t>
+            </a:r>
+          </a:p>
+          <a:p>
+            <a:pPr lvl="3"/>
+            <a:r>
+              <a:rPr lang="en-US"/>
+              <a:t>Fourth level</a:t>
+            </a:r>
+          </a:p>
+          <a:p>
+            <a:pPr lvl="4"/>
+            <a:r>
+              <a:rPr lang="en-US"/>
+              <a:t>Fifth level</a:t>
+            </a:r>
+          </a:p>
+        </p:txBody>
+      </p:sp>
+      <p:sp>
+        <p:nvSpPr>
+          <p:cNvPr id="5" name="Date Placeholder 4"/>
+          <p:cNvSpPr>
+            <a:spLocks noGrp="1"/>
+          </p:cNvSpPr>
+          <p:nvPr>
+            <p:ph type="dt" sz="half" idx="10"/>
+          </p:nvPr>
+        </p:nvSpPr>
+        <p:spPr/>
+        <p:txBody>
+          <a:bodyPr/>
+          <a:lstStyle/>
+          <a:p>
+            <a:fld id="{241EB5C9-1307-BA42-ABA2-0BC069CD8E7F}" type="datetimeFigureOut">
               <a:rPr lang="en-US" smtClean="0"/>
-              <a:t>Click to edit Master text styles</a:t>
-            </a:r>
-          </a:p>
-          <a:p>
-            <a:pPr lvl="1"/>
-            <a:r>
-              <a:rPr lang="en-US" smtClean="0"/>
-              <a:t>Second level</a:t>
-            </a:r>
-          </a:p>
-          <a:p>
-            <a:pPr lvl="2"/>
-            <a:r>
-              <a:rPr lang="en-US" smtClean="0"/>
-              <a:t>Third level</a:t>
-            </a:r>
-          </a:p>
-          <a:p>
-            <a:pPr lvl="3"/>
-            <a:r>
-              <a:rPr lang="en-US" smtClean="0"/>
-              <a:t>Fourth level</a:t>
-            </a:r>
-          </a:p>
-          <a:p>
-            <a:pPr lvl="4"/>
-            <a:r>
-              <a:rPr lang="en-US" smtClean="0"/>
-              <a:t>Fifth level</a:t>
-            </a:r>
-            <a:endParaRPr lang="en-US"/>
-          </a:p>
-        </p:txBody>
-      </p:sp>
-      <p:sp>
-        <p:nvSpPr>
-          <p:cNvPr id="5" name="Date Placeholder 4"/>
-          <p:cNvSpPr>
-            <a:spLocks noGrp="1"/>
-          </p:cNvSpPr>
-          <p:nvPr>
-            <p:ph type="dt" sz="half" idx="10"/>
-          </p:nvPr>
-        </p:nvSpPr>
-        <p:spPr/>
-        <p:txBody>
-          <a:bodyPr/>
-          <a:lstStyle/>
-          <a:p>
-            <a:fld id="{5BCAD085-E8A6-8845-BD4E-CB4CCA059FC4}" type="datetimeFigureOut">
-              <a:rPr lang="en-US" smtClean="0"/>
-              <a:t>1/27/13</a:t>
+              <a:t>1/2/22</a:t>
             </a:fld>
             <a:endParaRPr lang="en-US"/>
           </a:p>
@@ -1393,7 +1398,7 @@
           <a:bodyPr/>
           <a:lstStyle/>
           <a:p>
-            <a:fld id="{C1FF6DA9-008F-8B48-92A6-B652298478BF}" type="slidenum">
+            <a:fld id="{C5EF2332-01BF-834F-8236-50238282D533}" type="slidenum">
               <a:rPr lang="en-US" smtClean="0"/>
               <a:t>‹#›</a:t>
             </a:fld>
@@ -1404,7 +1409,7 @@
     </p:spTree>
     <p:extLst>
       <p:ext uri="{BB962C8B-B14F-4D97-AF65-F5344CB8AC3E}">
-        <p14:creationId xmlns:p14="http://schemas.microsoft.com/office/powerpoint/2010/main" val="2782244947"/>
+        <p14:creationId xmlns:p14="http://schemas.microsoft.com/office/powerpoint/2010/main" val="2619886245"/>
       </p:ext>
     </p:extLst>
   </p:cSld>
@@ -1451,10 +1456,9 @@
           </a:lstStyle>
           <a:p>
             <a:r>
-              <a:rPr lang="en-US" smtClean="0"/>
+              <a:rPr lang="en-US"/>
               <a:t>Click to edit Master title style</a:t>
             </a:r>
-            <a:endParaRPr lang="en-US"/>
           </a:p>
         </p:txBody>
       </p:sp>
@@ -1470,8 +1474,8 @@
         </p:nvSpPr>
         <p:spPr>
           <a:xfrm>
-            <a:off x="457200" y="1535113"/>
-            <a:ext cx="4040188" cy="639762"/>
+            <a:off x="457200" y="1151335"/>
+            <a:ext cx="4040188" cy="479822"/>
           </a:xfrm>
         </p:spPr>
         <p:txBody>
@@ -1479,45 +1483,45 @@
           <a:lstStyle>
             <a:lvl1pPr marL="0" indent="0">
               <a:buNone/>
-              <a:defRPr sz="2400" b="1"/>
+              <a:defRPr sz="1800" b="1"/>
             </a:lvl1pPr>
-            <a:lvl2pPr marL="457200" indent="0">
-              <a:buNone/>
-              <a:defRPr sz="2000" b="1"/>
+            <a:lvl2pPr marL="342900" indent="0">
+              <a:buNone/>
+              <a:defRPr sz="1500" b="1"/>
             </a:lvl2pPr>
-            <a:lvl3pPr marL="914400" indent="0">
-              <a:buNone/>
-              <a:defRPr sz="1800" b="1"/>
+            <a:lvl3pPr marL="685800" indent="0">
+              <a:buNone/>
+              <a:defRPr sz="1350" b="1"/>
             </a:lvl3pPr>
-            <a:lvl4pPr marL="1371600" indent="0">
-              <a:buNone/>
-              <a:defRPr sz="1600" b="1"/>
+            <a:lvl4pPr marL="1028700" indent="0">
+              <a:buNone/>
+              <a:defRPr sz="1200" b="1"/>
             </a:lvl4pPr>
-            <a:lvl5pPr marL="1828800" indent="0">
-              <a:buNone/>
-              <a:defRPr sz="1600" b="1"/>
+            <a:lvl5pPr marL="1371600" indent="0">
+              <a:buNone/>
+              <a:defRPr sz="1200" b="1"/>
             </a:lvl5pPr>
-            <a:lvl6pPr marL="2286000" indent="0">
-              <a:buNone/>
-              <a:defRPr sz="1600" b="1"/>
+            <a:lvl6pPr marL="1714500" indent="0">
+              <a:buNone/>
+              <a:defRPr sz="1200" b="1"/>
             </a:lvl6pPr>
-            <a:lvl7pPr marL="2743200" indent="0">
-              <a:buNone/>
-              <a:defRPr sz="1600" b="1"/>
+            <a:lvl7pPr marL="2057400" indent="0">
+              <a:buNone/>
+              <a:defRPr sz="1200" b="1"/>
             </a:lvl7pPr>
-            <a:lvl8pPr marL="3200400" indent="0">
-              <a:buNone/>
-              <a:defRPr sz="1600" b="1"/>
+            <a:lvl8pPr marL="2400300" indent="0">
+              <a:buNone/>
+              <a:defRPr sz="1200" b="1"/>
             </a:lvl8pPr>
-            <a:lvl9pPr marL="3657600" indent="0">
-              <a:buNone/>
-              <a:defRPr sz="1600" b="1"/>
+            <a:lvl9pPr marL="2743200" indent="0">
+              <a:buNone/>
+              <a:defRPr sz="1200" b="1"/>
             </a:lvl9pPr>
           </a:lstStyle>
           <a:p>
             <a:pPr lvl="0"/>
             <a:r>
-              <a:rPr lang="en-US" smtClean="0"/>
+              <a:rPr lang="en-US"/>
               <a:t>Click to edit Master text styles</a:t>
             </a:r>
           </a:p>
@@ -1535,76 +1539,75 @@
         </p:nvSpPr>
         <p:spPr>
           <a:xfrm>
-            <a:off x="457200" y="2174875"/>
-            <a:ext cx="4040188" cy="3951288"/>
+            <a:off x="457200" y="1631156"/>
+            <a:ext cx="4040188" cy="2963466"/>
           </a:xfrm>
         </p:spPr>
         <p:txBody>
           <a:bodyPr/>
           <a:lstStyle>
             <a:lvl1pPr>
-              <a:defRPr sz="2400"/>
+              <a:defRPr sz="1800"/>
             </a:lvl1pPr>
             <a:lvl2pPr>
-              <a:defRPr sz="2000"/>
+              <a:defRPr sz="1500"/>
             </a:lvl2pPr>
             <a:lvl3pPr>
-              <a:defRPr sz="1800"/>
+              <a:defRPr sz="1350"/>
             </a:lvl3pPr>
             <a:lvl4pPr>
-              <a:defRPr sz="1600"/>
+              <a:defRPr sz="1200"/>
             </a:lvl4pPr>
             <a:lvl5pPr>
-              <a:defRPr sz="1600"/>
+              <a:defRPr sz="1200"/>
             </a:lvl5pPr>
             <a:lvl6pPr>
-              <a:defRPr sz="1600"/>
+              <a:defRPr sz="1200"/>
             </a:lvl6pPr>
             <a:lvl7pPr>
-              <a:defRPr sz="1600"/>
+              <a:defRPr sz="1200"/>
             </a:lvl7pPr>
             <a:lvl8pPr>
-              <a:defRPr sz="1600"/>
+              <a:defRPr sz="1200"/>
             </a:lvl8pPr>
             <a:lvl9pPr>
-              <a:defRPr sz="1600"/>
+              <a:defRPr sz="1200"/>
             </a:lvl9pPr>
           </a:lstStyle>
           <a:p>
             <a:pPr lvl="0"/>
             <a:r>
-              <a:rPr lang="en-US" smtClean="0"/>
+              <a:rPr lang="en-US"/>
               <a:t>Click to edit Master text styles</a:t>
             </a:r>
           </a:p>
           <a:p>
             <a:pPr lvl="1"/>
             <a:r>
-              <a:rPr lang="en-US" smtClean="0"/>
+              <a:rPr lang="en-US"/>
               <a:t>Second level</a:t>
             </a:r>
           </a:p>
           <a:p>
             <a:pPr lvl="2"/>
             <a:r>
-              <a:rPr lang="en-US" smtClean="0"/>
+              <a:rPr lang="en-US"/>
               <a:t>Third level</a:t>
             </a:r>
           </a:p>
           <a:p>
             <a:pPr lvl="3"/>
             <a:r>
-              <a:rPr lang="en-US" smtClean="0"/>
+              <a:rPr lang="en-US"/>
               <a:t>Fourth level</a:t>
             </a:r>
           </a:p>
           <a:p>
             <a:pPr lvl="4"/>
             <a:r>
-              <a:rPr lang="en-US" smtClean="0"/>
+              <a:rPr lang="en-US"/>
               <a:t>Fifth level</a:t>
             </a:r>
-            <a:endParaRPr lang="en-US"/>
           </a:p>
         </p:txBody>
       </p:sp>
@@ -1620,8 +1623,8 @@
         </p:nvSpPr>
         <p:spPr>
           <a:xfrm>
-            <a:off x="4645025" y="1535113"/>
-            <a:ext cx="4041775" cy="639762"/>
+            <a:off x="4645026" y="1151335"/>
+            <a:ext cx="4041775" cy="479822"/>
           </a:xfrm>
         </p:spPr>
         <p:txBody>
@@ -1629,45 +1632,45 @@
           <a:lstStyle>
             <a:lvl1pPr marL="0" indent="0">
               <a:buNone/>
-              <a:defRPr sz="2400" b="1"/>
+              <a:defRPr sz="1800" b="1"/>
             </a:lvl1pPr>
-            <a:lvl2pPr marL="457200" indent="0">
-              <a:buNone/>
-              <a:defRPr sz="2000" b="1"/>
+            <a:lvl2pPr marL="342900" indent="0">
+              <a:buNone/>
+              <a:defRPr sz="1500" b="1"/>
             </a:lvl2pPr>
-            <a:lvl3pPr marL="914400" indent="0">
-              <a:buNone/>
-              <a:defRPr sz="1800" b="1"/>
+            <a:lvl3pPr marL="685800" indent="0">
+              <a:buNone/>
+              <a:defRPr sz="1350" b="1"/>
             </a:lvl3pPr>
-            <a:lvl4pPr marL="1371600" indent="0">
-              <a:buNone/>
-              <a:defRPr sz="1600" b="1"/>
+            <a:lvl4pPr marL="1028700" indent="0">
+              <a:buNone/>
+              <a:defRPr sz="1200" b="1"/>
             </a:lvl4pPr>
-            <a:lvl5pPr marL="1828800" indent="0">
-              <a:buNone/>
-              <a:defRPr sz="1600" b="1"/>
+            <a:lvl5pPr marL="1371600" indent="0">
+              <a:buNone/>
+              <a:defRPr sz="1200" b="1"/>
             </a:lvl5pPr>
-            <a:lvl6pPr marL="2286000" indent="0">
-              <a:buNone/>
-              <a:defRPr sz="1600" b="1"/>
+            <a:lvl6pPr marL="1714500" indent="0">
+              <a:buNone/>
+              <a:defRPr sz="1200" b="1"/>
             </a:lvl6pPr>
-            <a:lvl7pPr marL="2743200" indent="0">
-              <a:buNone/>
-              <a:defRPr sz="1600" b="1"/>
+            <a:lvl7pPr marL="2057400" indent="0">
+              <a:buNone/>
+              <a:defRPr sz="1200" b="1"/>
             </a:lvl7pPr>
-            <a:lvl8pPr marL="3200400" indent="0">
-              <a:buNone/>
-              <a:defRPr sz="1600" b="1"/>
+            <a:lvl8pPr marL="2400300" indent="0">
+              <a:buNone/>
+              <a:defRPr sz="1200" b="1"/>
             </a:lvl8pPr>
-            <a:lvl9pPr marL="3657600" indent="0">
-              <a:buNone/>
-              <a:defRPr sz="1600" b="1"/>
+            <a:lvl9pPr marL="2743200" indent="0">
+              <a:buNone/>
+              <a:defRPr sz="1200" b="1"/>
             </a:lvl9pPr>
           </a:lstStyle>
           <a:p>
             <a:pPr lvl="0"/>
             <a:r>
-              <a:rPr lang="en-US" smtClean="0"/>
+              <a:rPr lang="en-US"/>
               <a:t>Click to edit Master text styles</a:t>
             </a:r>
           </a:p>
@@ -1685,97 +1688,96 @@
         </p:nvSpPr>
         <p:spPr>
           <a:xfrm>
-            <a:off x="4645025" y="2174875"/>
-            <a:ext cx="4041775" cy="3951288"/>
+            <a:off x="4645026" y="1631156"/>
+            <a:ext cx="4041775" cy="2963466"/>
           </a:xfrm>
         </p:spPr>
         <p:txBody>
           <a:bodyPr/>
           <a:lstStyle>
             <a:lvl1pPr>
-              <a:defRPr sz="2400"/>
+              <a:defRPr sz="1800"/>
             </a:lvl1pPr>
             <a:lvl2pPr>
-              <a:defRPr sz="2000"/>
+              <a:defRPr sz="1500"/>
             </a:lvl2pPr>
             <a:lvl3pPr>
-              <a:defRPr sz="1800"/>
+              <a:defRPr sz="1350"/>
             </a:lvl3pPr>
             <a:lvl4pPr>
-              <a:defRPr sz="1600"/>
+              <a:defRPr sz="1200"/>
             </a:lvl4pPr>
             <a:lvl5pPr>
-              <a:defRPr sz="1600"/>
+              <a:defRPr sz="1200"/>
             </a:lvl5pPr>
             <a:lvl6pPr>
-              <a:defRPr sz="1600"/>
+              <a:defRPr sz="1200"/>
             </a:lvl6pPr>
             <a:lvl7pPr>
-              <a:defRPr sz="1600"/>
+              <a:defRPr sz="1200"/>
             </a:lvl7pPr>
             <a:lvl8pPr>
-              <a:defRPr sz="1600"/>
+              <a:defRPr sz="1200"/>
             </a:lvl8pPr>
             <a:lvl9pPr>
-              <a:defRPr sz="1600"/>
+              <a:defRPr sz="1200"/>
             </a:lvl9pPr>
           </a:lstStyle>
           <a:p>
             <a:pPr lvl="0"/>
             <a:r>
+              <a:rPr lang="en-US"/>
+              <a:t>Click to edit Master text styles</a:t>
+            </a:r>
+          </a:p>
+          <a:p>
+            <a:pPr lvl="1"/>
+            <a:r>
+              <a:rPr lang="en-US"/>
+              <a:t>Second level</a:t>
+            </a:r>
+          </a:p>
+          <a:p>
+            <a:pPr lvl="2"/>
+            <a:r>
+              <a:rPr lang="en-US"/>
+              <a:t>Third level</a:t>
+            </a:r>
+          </a:p>
+          <a:p>
+            <a:pPr lvl="3"/>
+            <a:r>
+              <a:rPr lang="en-US"/>
+              <a:t>Fourth level</a:t>
+            </a:r>
+          </a:p>
+          <a:p>
+            <a:pPr lvl="4"/>
+            <a:r>
+              <a:rPr lang="en-US"/>
+              <a:t>Fifth level</a:t>
+            </a:r>
+          </a:p>
+        </p:txBody>
+      </p:sp>
+      <p:sp>
+        <p:nvSpPr>
+          <p:cNvPr id="7" name="Date Placeholder 6"/>
+          <p:cNvSpPr>
+            <a:spLocks noGrp="1"/>
+          </p:cNvSpPr>
+          <p:nvPr>
+            <p:ph type="dt" sz="half" idx="10"/>
+          </p:nvPr>
+        </p:nvSpPr>
+        <p:spPr/>
+        <p:txBody>
+          <a:bodyPr/>
+          <a:lstStyle/>
+          <a:p>
+            <a:fld id="{241EB5C9-1307-BA42-ABA2-0BC069CD8E7F}" type="datetimeFigureOut">
               <a:rPr lang="en-US" smtClean="0"/>
-              <a:t>Click to edit Master text styles</a:t>
-            </a:r>
-          </a:p>
-          <a:p>
-            <a:pPr lvl="1"/>
-            <a:r>
-              <a:rPr lang="en-US" smtClean="0"/>
-              <a:t>Second level</a:t>
-            </a:r>
-          </a:p>
-          <a:p>
-            <a:pPr lvl="2"/>
-            <a:r>
-              <a:rPr lang="en-US" smtClean="0"/>
-              <a:t>Third level</a:t>
-            </a:r>
-          </a:p>
-          <a:p>
-            <a:pPr lvl="3"/>
-            <a:r>
-              <a:rPr lang="en-US" smtClean="0"/>
-              <a:t>Fourth level</a:t>
-            </a:r>
-          </a:p>
-          <a:p>
-            <a:pPr lvl="4"/>
-            <a:r>
-              <a:rPr lang="en-US" smtClean="0"/>
-              <a:t>Fifth level</a:t>
-            </a:r>
-            <a:endParaRPr lang="en-US"/>
-          </a:p>
-        </p:txBody>
-      </p:sp>
-      <p:sp>
-        <p:nvSpPr>
-          <p:cNvPr id="7" name="Date Placeholder 6"/>
-          <p:cNvSpPr>
-            <a:spLocks noGrp="1"/>
-          </p:cNvSpPr>
-          <p:nvPr>
-            <p:ph type="dt" sz="half" idx="10"/>
-          </p:nvPr>
-        </p:nvSpPr>
-        <p:spPr/>
-        <p:txBody>
-          <a:bodyPr/>
-          <a:lstStyle/>
-          <a:p>
-            <a:fld id="{5BCAD085-E8A6-8845-BD4E-CB4CCA059FC4}" type="datetimeFigureOut">
-              <a:rPr lang="en-US" smtClean="0"/>
-              <a:t>1/27/13</a:t>
+              <a:t>1/2/22</a:t>
             </a:fld>
             <a:endParaRPr lang="en-US"/>
           </a:p>
@@ -1815,7 +1817,7 @@
           <a:bodyPr/>
           <a:lstStyle/>
           <a:p>
-            <a:fld id="{C1FF6DA9-008F-8B48-92A6-B652298478BF}" type="slidenum">
+            <a:fld id="{C5EF2332-01BF-834F-8236-50238282D533}" type="slidenum">
               <a:rPr lang="en-US" smtClean="0"/>
               <a:t>‹#›</a:t>
             </a:fld>
@@ -1826,7 +1828,7 @@
     </p:spTree>
     <p:extLst>
       <p:ext uri="{BB962C8B-B14F-4D97-AF65-F5344CB8AC3E}">
-        <p14:creationId xmlns:p14="http://schemas.microsoft.com/office/powerpoint/2010/main" val="990158736"/>
+        <p14:creationId xmlns:p14="http://schemas.microsoft.com/office/powerpoint/2010/main" val="2535793967"/>
       </p:ext>
     </p:extLst>
   </p:cSld>
@@ -1869,31 +1871,30 @@
           <a:lstStyle/>
           <a:p>
             <a:r>
+              <a:rPr lang="en-US"/>
+              <a:t>Click to edit Master title style</a:t>
+            </a:r>
+          </a:p>
+        </p:txBody>
+      </p:sp>
+      <p:sp>
+        <p:nvSpPr>
+          <p:cNvPr id="3" name="Date Placeholder 2"/>
+          <p:cNvSpPr>
+            <a:spLocks noGrp="1"/>
+          </p:cNvSpPr>
+          <p:nvPr>
+            <p:ph type="dt" sz="half" idx="10"/>
+          </p:nvPr>
+        </p:nvSpPr>
+        <p:spPr/>
+        <p:txBody>
+          <a:bodyPr/>
+          <a:lstStyle/>
+          <a:p>
+            <a:fld id="{241EB5C9-1307-BA42-ABA2-0BC069CD8E7F}" type="datetimeFigureOut">
               <a:rPr lang="en-US" smtClean="0"/>
-              <a:t>Click to edit Master title style</a:t>
-            </a:r>
-            <a:endParaRPr lang="en-US"/>
-          </a:p>
-        </p:txBody>
-      </p:sp>
-      <p:sp>
-        <p:nvSpPr>
-          <p:cNvPr id="3" name="Date Placeholder 2"/>
-          <p:cNvSpPr>
-            <a:spLocks noGrp="1"/>
-          </p:cNvSpPr>
-          <p:nvPr>
-            <p:ph type="dt" sz="half" idx="10"/>
-          </p:nvPr>
-        </p:nvSpPr>
-        <p:spPr/>
-        <p:txBody>
-          <a:bodyPr/>
-          <a:lstStyle/>
-          <a:p>
-            <a:fld id="{5BCAD085-E8A6-8845-BD4E-CB4CCA059FC4}" type="datetimeFigureOut">
-              <a:rPr lang="en-US" smtClean="0"/>
-              <a:t>1/27/13</a:t>
+              <a:t>1/2/22</a:t>
             </a:fld>
             <a:endParaRPr lang="en-US"/>
           </a:p>
@@ -1933,7 +1934,7 @@
           <a:bodyPr/>
           <a:lstStyle/>
           <a:p>
-            <a:fld id="{C1FF6DA9-008F-8B48-92A6-B652298478BF}" type="slidenum">
+            <a:fld id="{C5EF2332-01BF-834F-8236-50238282D533}" type="slidenum">
               <a:rPr lang="en-US" smtClean="0"/>
               <a:t>‹#›</a:t>
             </a:fld>
@@ -1944,7 +1945,7 @@
     </p:spTree>
     <p:extLst>
       <p:ext uri="{BB962C8B-B14F-4D97-AF65-F5344CB8AC3E}">
-        <p14:creationId xmlns:p14="http://schemas.microsoft.com/office/powerpoint/2010/main" val="727027711"/>
+        <p14:creationId xmlns:p14="http://schemas.microsoft.com/office/powerpoint/2010/main" val="3472721253"/>
       </p:ext>
     </p:extLst>
   </p:cSld>
@@ -1986,9 +1987,9 @@
           <a:bodyPr/>
           <a:lstStyle/>
           <a:p>
-            <a:fld id="{5BCAD085-E8A6-8845-BD4E-CB4CCA059FC4}" type="datetimeFigureOut">
+            <a:fld id="{241EB5C9-1307-BA42-ABA2-0BC069CD8E7F}" type="datetimeFigureOut">
               <a:rPr lang="en-US" smtClean="0"/>
-              <a:t>1/27/13</a:t>
+              <a:t>1/2/22</a:t>
             </a:fld>
             <a:endParaRPr lang="en-US"/>
           </a:p>
@@ -2028,7 +2029,7 @@
           <a:bodyPr/>
           <a:lstStyle/>
           <a:p>
-            <a:fld id="{C1FF6DA9-008F-8B48-92A6-B652298478BF}" type="slidenum">
+            <a:fld id="{C5EF2332-01BF-834F-8236-50238282D533}" type="slidenum">
               <a:rPr lang="en-US" smtClean="0"/>
               <a:t>‹#›</a:t>
             </a:fld>
@@ -2039,7 +2040,7 @@
     </p:spTree>
     <p:extLst>
       <p:ext uri="{BB962C8B-B14F-4D97-AF65-F5344CB8AC3E}">
-        <p14:creationId xmlns:p14="http://schemas.microsoft.com/office/powerpoint/2010/main" val="1212999818"/>
+        <p14:creationId xmlns:p14="http://schemas.microsoft.com/office/powerpoint/2010/main" val="2130901097"/>
       </p:ext>
     </p:extLst>
   </p:cSld>
@@ -2078,23 +2079,22 @@
         </p:nvSpPr>
         <p:spPr>
           <a:xfrm>
-            <a:off x="457200" y="273050"/>
-            <a:ext cx="3008313" cy="1162050"/>
+            <a:off x="457201" y="204787"/>
+            <a:ext cx="3008313" cy="871538"/>
           </a:xfrm>
         </p:spPr>
         <p:txBody>
           <a:bodyPr anchor="b"/>
           <a:lstStyle>
             <a:lvl1pPr algn="l">
-              <a:defRPr sz="2000" b="1"/>
+              <a:defRPr sz="1500" b="1"/>
             </a:lvl1pPr>
           </a:lstStyle>
           <a:p>
             <a:r>
-              <a:rPr lang="en-US" smtClean="0"/>
+              <a:rPr lang="en-US"/>
               <a:t>Click to edit Master title style</a:t>
             </a:r>
-            <a:endParaRPr lang="en-US"/>
           </a:p>
         </p:txBody>
       </p:sp>
@@ -2110,76 +2110,75 @@
         </p:nvSpPr>
         <p:spPr>
           <a:xfrm>
-            <a:off x="3575050" y="273050"/>
-            <a:ext cx="5111750" cy="5853113"/>
+            <a:off x="3575050" y="204788"/>
+            <a:ext cx="5111750" cy="4389835"/>
           </a:xfrm>
         </p:spPr>
         <p:txBody>
           <a:bodyPr/>
           <a:lstStyle>
             <a:lvl1pPr>
-              <a:defRPr sz="3200"/>
+              <a:defRPr sz="2400"/>
             </a:lvl1pPr>
             <a:lvl2pPr>
-              <a:defRPr sz="2800"/>
+              <a:defRPr sz="2100"/>
             </a:lvl2pPr>
             <a:lvl3pPr>
-              <a:defRPr sz="2400"/>
+              <a:defRPr sz="1800"/>
             </a:lvl3pPr>
             <a:lvl4pPr>
-              <a:defRPr sz="2000"/>
+              <a:defRPr sz="1500"/>
             </a:lvl4pPr>
             <a:lvl5pPr>
-              <a:defRPr sz="2000"/>
+              <a:defRPr sz="1500"/>
             </a:lvl5pPr>
             <a:lvl6pPr>
-              <a:defRPr sz="2000"/>
+              <a:defRPr sz="1500"/>
             </a:lvl6pPr>
             <a:lvl7pPr>
-              <a:defRPr sz="2000"/>
+              <a:defRPr sz="1500"/>
             </a:lvl7pPr>
             <a:lvl8pPr>
-              <a:defRPr sz="2000"/>
+              <a:defRPr sz="1500"/>
             </a:lvl8pPr>
             <a:lvl9pPr>
-              <a:defRPr sz="2000"/>
+              <a:defRPr sz="1500"/>
             </a:lvl9pPr>
           </a:lstStyle>
           <a:p>
             <a:pPr lvl="0"/>
             <a:r>
-              <a:rPr lang="en-US" smtClean="0"/>
+              <a:rPr lang="en-US"/>
               <a:t>Click to edit Master text styles</a:t>
             </a:r>
           </a:p>
           <a:p>
             <a:pPr lvl="1"/>
             <a:r>
-              <a:rPr lang="en-US" smtClean="0"/>
+              <a:rPr lang="en-US"/>
               <a:t>Second level</a:t>
             </a:r>
           </a:p>
           <a:p>
             <a:pPr lvl="2"/>
             <a:r>
-              <a:rPr lang="en-US" smtClean="0"/>
+              <a:rPr lang="en-US"/>
               <a:t>Third level</a:t>
             </a:r>
           </a:p>
           <a:p>
             <a:pPr lvl="3"/>
             <a:r>
-              <a:rPr lang="en-US" smtClean="0"/>
+              <a:rPr lang="en-US"/>
               <a:t>Fourth level</a:t>
             </a:r>
           </a:p>
           <a:p>
             <a:pPr lvl="4"/>
             <a:r>
-              <a:rPr lang="en-US" smtClean="0"/>
+              <a:rPr lang="en-US"/>
               <a:t>Fifth level</a:t>
             </a:r>
-            <a:endParaRPr lang="en-US"/>
           </a:p>
         </p:txBody>
       </p:sp>
@@ -2195,8 +2194,8 @@
         </p:nvSpPr>
         <p:spPr>
           <a:xfrm>
-            <a:off x="457200" y="1435100"/>
-            <a:ext cx="3008313" cy="4691063"/>
+            <a:off x="457201" y="1076326"/>
+            <a:ext cx="3008313" cy="3518297"/>
           </a:xfrm>
         </p:spPr>
         <p:txBody>
@@ -2204,68 +2203,68 @@
           <a:lstStyle>
             <a:lvl1pPr marL="0" indent="0">
               <a:buNone/>
-              <a:defRPr sz="1400"/>
+              <a:defRPr sz="1050"/>
             </a:lvl1pPr>
-            <a:lvl2pPr marL="457200" indent="0">
-              <a:buNone/>
-              <a:defRPr sz="1200"/>
+            <a:lvl2pPr marL="342900" indent="0">
+              <a:buNone/>
+              <a:defRPr sz="900"/>
             </a:lvl2pPr>
-            <a:lvl3pPr marL="914400" indent="0">
-              <a:buNone/>
-              <a:defRPr sz="1000"/>
+            <a:lvl3pPr marL="685800" indent="0">
+              <a:buNone/>
+              <a:defRPr sz="750"/>
             </a:lvl3pPr>
-            <a:lvl4pPr marL="1371600" indent="0">
-              <a:buNone/>
-              <a:defRPr sz="900"/>
+            <a:lvl4pPr marL="1028700" indent="0">
+              <a:buNone/>
+              <a:defRPr sz="675"/>
             </a:lvl4pPr>
-            <a:lvl5pPr marL="1828800" indent="0">
-              <a:buNone/>
-              <a:defRPr sz="900"/>
+            <a:lvl5pPr marL="1371600" indent="0">
+              <a:buNone/>
+              <a:defRPr sz="675"/>
             </a:lvl5pPr>
-            <a:lvl6pPr marL="2286000" indent="0">
-              <a:buNone/>
-              <a:defRPr sz="900"/>
+            <a:lvl6pPr marL="1714500" indent="0">
+              <a:buNone/>
+              <a:defRPr sz="675"/>
             </a:lvl6pPr>
-            <a:lvl7pPr marL="2743200" indent="0">
-              <a:buNone/>
-              <a:defRPr sz="900"/>
+            <a:lvl7pPr marL="2057400" indent="0">
+              <a:buNone/>
+              <a:defRPr sz="675"/>
             </a:lvl7pPr>
-            <a:lvl8pPr marL="3200400" indent="0">
-              <a:buNone/>
-              <a:defRPr sz="900"/>
+            <a:lvl8pPr marL="2400300" indent="0">
+              <a:buNone/>
+              <a:defRPr sz="675"/>
             </a:lvl8pPr>
-            <a:lvl9pPr marL="3657600" indent="0">
-              <a:buNone/>
-              <a:defRPr sz="900"/>
+            <a:lvl9pPr marL="2743200" indent="0">
+              <a:buNone/>
+              <a:defRPr sz="675"/>
             </a:lvl9pPr>
           </a:lstStyle>
           <a:p>
             <a:pPr lvl="0"/>
             <a:r>
+              <a:rPr lang="en-US"/>
+              <a:t>Click to edit Master text styles</a:t>
+            </a:r>
+          </a:p>
+        </p:txBody>
+      </p:sp>
+      <p:sp>
+        <p:nvSpPr>
+          <p:cNvPr id="5" name="Date Placeholder 4"/>
+          <p:cNvSpPr>
+            <a:spLocks noGrp="1"/>
+          </p:cNvSpPr>
+          <p:nvPr>
+            <p:ph type="dt" sz="half" idx="10"/>
+          </p:nvPr>
+        </p:nvSpPr>
+        <p:spPr/>
+        <p:txBody>
+          <a:bodyPr/>
+          <a:lstStyle/>
+          <a:p>
+            <a:fld id="{241EB5C9-1307-BA42-ABA2-0BC069CD8E7F}" type="datetimeFigureOut">
               <a:rPr lang="en-US" smtClean="0"/>
-              <a:t>Click to edit Master text styles</a:t>
-            </a:r>
-          </a:p>
-        </p:txBody>
-      </p:sp>
-      <p:sp>
-        <p:nvSpPr>
-          <p:cNvPr id="5" name="Date Placeholder 4"/>
-          <p:cNvSpPr>
-            <a:spLocks noGrp="1"/>
-          </p:cNvSpPr>
-          <p:nvPr>
-            <p:ph type="dt" sz="half" idx="10"/>
-          </p:nvPr>
-        </p:nvSpPr>
-        <p:spPr/>
-        <p:txBody>
-          <a:bodyPr/>
-          <a:lstStyle/>
-          <a:p>
-            <a:fld id="{5BCAD085-E8A6-8845-BD4E-CB4CCA059FC4}" type="datetimeFigureOut">
-              <a:rPr lang="en-US" smtClean="0"/>
-              <a:t>1/27/13</a:t>
+              <a:t>1/2/22</a:t>
             </a:fld>
             <a:endParaRPr lang="en-US"/>
           </a:p>
@@ -2305,7 +2304,7 @@
           <a:bodyPr/>
           <a:lstStyle/>
           <a:p>
-            <a:fld id="{C1FF6DA9-008F-8B48-92A6-B652298478BF}" type="slidenum">
+            <a:fld id="{C5EF2332-01BF-834F-8236-50238282D533}" type="slidenum">
               <a:rPr lang="en-US" smtClean="0"/>
               <a:t>‹#›</a:t>
             </a:fld>
@@ -2316,7 +2315,7 @@
     </p:spTree>
     <p:extLst>
       <p:ext uri="{BB962C8B-B14F-4D97-AF65-F5344CB8AC3E}">
-        <p14:creationId xmlns:p14="http://schemas.microsoft.com/office/powerpoint/2010/main" val="1840726560"/>
+        <p14:creationId xmlns:p14="http://schemas.microsoft.com/office/powerpoint/2010/main" val="3540895647"/>
       </p:ext>
     </p:extLst>
   </p:cSld>
@@ -2355,23 +2354,22 @@
         </p:nvSpPr>
         <p:spPr>
           <a:xfrm>
-            <a:off x="1792288" y="4800600"/>
-            <a:ext cx="5486400" cy="566738"/>
+            <a:off x="1792288" y="3600450"/>
+            <a:ext cx="5486400" cy="425054"/>
           </a:xfrm>
         </p:spPr>
         <p:txBody>
           <a:bodyPr anchor="b"/>
           <a:lstStyle>
             <a:lvl1pPr algn="l">
-              <a:defRPr sz="2000" b="1"/>
+              <a:defRPr sz="1500" b="1"/>
             </a:lvl1pPr>
           </a:lstStyle>
           <a:p>
             <a:r>
-              <a:rPr lang="en-US" smtClean="0"/>
+              <a:rPr lang="en-US"/>
               <a:t>Click to edit Master title style</a:t>
             </a:r>
-            <a:endParaRPr lang="en-US"/>
           </a:p>
         </p:txBody>
       </p:sp>
@@ -2387,8 +2385,8 @@
         </p:nvSpPr>
         <p:spPr>
           <a:xfrm>
-            <a:off x="1792288" y="612775"/>
-            <a:ext cx="5486400" cy="4114800"/>
+            <a:off x="1792288" y="459581"/>
+            <a:ext cx="5486400" cy="3086100"/>
           </a:xfrm>
         </p:spPr>
         <p:txBody>
@@ -2396,39 +2394,39 @@
           <a:lstStyle>
             <a:lvl1pPr marL="0" indent="0">
               <a:buNone/>
-              <a:defRPr sz="3200"/>
+              <a:defRPr sz="2400"/>
             </a:lvl1pPr>
-            <a:lvl2pPr marL="457200" indent="0">
-              <a:buNone/>
-              <a:defRPr sz="2800"/>
+            <a:lvl2pPr marL="342900" indent="0">
+              <a:buNone/>
+              <a:defRPr sz="2100"/>
             </a:lvl2pPr>
-            <a:lvl3pPr marL="914400" indent="0">
-              <a:buNone/>
-              <a:defRPr sz="2400"/>
+            <a:lvl3pPr marL="685800" indent="0">
+              <a:buNone/>
+              <a:defRPr sz="1800"/>
             </a:lvl3pPr>
-            <a:lvl4pPr marL="1371600" indent="0">
-              <a:buNone/>
-              <a:defRPr sz="2000"/>
+            <a:lvl4pPr marL="1028700" indent="0">
+              <a:buNone/>
+              <a:defRPr sz="1500"/>
             </a:lvl4pPr>
-            <a:lvl5pPr marL="1828800" indent="0">
-              <a:buNone/>
-              <a:defRPr sz="2000"/>
+            <a:lvl5pPr marL="1371600" indent="0">
+              <a:buNone/>
+              <a:defRPr sz="1500"/>
             </a:lvl5pPr>
-            <a:lvl6pPr marL="2286000" indent="0">
-              <a:buNone/>
-              <a:defRPr sz="2000"/>
+            <a:lvl6pPr marL="1714500" indent="0">
+              <a:buNone/>
+              <a:defRPr sz="1500"/>
             </a:lvl6pPr>
-            <a:lvl7pPr marL="2743200" indent="0">
-              <a:buNone/>
-              <a:defRPr sz="2000"/>
+            <a:lvl7pPr marL="2057400" indent="0">
+              <a:buNone/>
+              <a:defRPr sz="1500"/>
             </a:lvl7pPr>
-            <a:lvl8pPr marL="3200400" indent="0">
-              <a:buNone/>
-              <a:defRPr sz="2000"/>
+            <a:lvl8pPr marL="2400300" indent="0">
+              <a:buNone/>
+              <a:defRPr sz="1500"/>
             </a:lvl8pPr>
-            <a:lvl9pPr marL="3657600" indent="0">
-              <a:buNone/>
-              <a:defRPr sz="2000"/>
+            <a:lvl9pPr marL="2743200" indent="0">
+              <a:buNone/>
+              <a:defRPr sz="1500"/>
             </a:lvl9pPr>
           </a:lstStyle>
           <a:p>
@@ -2448,8 +2446,8 @@
         </p:nvSpPr>
         <p:spPr>
           <a:xfrm>
-            <a:off x="1792288" y="5367338"/>
-            <a:ext cx="5486400" cy="804862"/>
+            <a:off x="1792288" y="4025503"/>
+            <a:ext cx="5486400" cy="603647"/>
           </a:xfrm>
         </p:spPr>
         <p:txBody>
@@ -2457,68 +2455,68 @@
           <a:lstStyle>
             <a:lvl1pPr marL="0" indent="0">
               <a:buNone/>
-              <a:defRPr sz="1400"/>
+              <a:defRPr sz="1050"/>
             </a:lvl1pPr>
-            <a:lvl2pPr marL="457200" indent="0">
-              <a:buNone/>
-              <a:defRPr sz="1200"/>
+            <a:lvl2pPr marL="342900" indent="0">
+              <a:buNone/>
+              <a:defRPr sz="900"/>
             </a:lvl2pPr>
-            <a:lvl3pPr marL="914400" indent="0">
-              <a:buNone/>
-              <a:defRPr sz="1000"/>
+            <a:lvl3pPr marL="685800" indent="0">
+              <a:buNone/>
+              <a:defRPr sz="750"/>
             </a:lvl3pPr>
-            <a:lvl4pPr marL="1371600" indent="0">
-              <a:buNone/>
-              <a:defRPr sz="900"/>
+            <a:lvl4pPr marL="1028700" indent="0">
+              <a:buNone/>
+              <a:defRPr sz="675"/>
             </a:lvl4pPr>
-            <a:lvl5pPr marL="1828800" indent="0">
-              <a:buNone/>
-              <a:defRPr sz="900"/>
+            <a:lvl5pPr marL="1371600" indent="0">
+              <a:buNone/>
+              <a:defRPr sz="675"/>
             </a:lvl5pPr>
-            <a:lvl6pPr marL="2286000" indent="0">
-              <a:buNone/>
-              <a:defRPr sz="900"/>
+            <a:lvl6pPr marL="1714500" indent="0">
+              <a:buNone/>
+              <a:defRPr sz="675"/>
             </a:lvl6pPr>
-            <a:lvl7pPr marL="2743200" indent="0">
-              <a:buNone/>
-              <a:defRPr sz="900"/>
+            <a:lvl7pPr marL="2057400" indent="0">
+              <a:buNone/>
+              <a:defRPr sz="675"/>
             </a:lvl7pPr>
-            <a:lvl8pPr marL="3200400" indent="0">
-              <a:buNone/>
-              <a:defRPr sz="900"/>
+            <a:lvl8pPr marL="2400300" indent="0">
+              <a:buNone/>
+              <a:defRPr sz="675"/>
             </a:lvl8pPr>
-            <a:lvl9pPr marL="3657600" indent="0">
-              <a:buNone/>
-              <a:defRPr sz="900"/>
+            <a:lvl9pPr marL="2743200" indent="0">
+              <a:buNone/>
+              <a:defRPr sz="675"/>
             </a:lvl9pPr>
           </a:lstStyle>
           <a:p>
             <a:pPr lvl="0"/>
             <a:r>
+              <a:rPr lang="en-US"/>
+              <a:t>Click to edit Master text styles</a:t>
+            </a:r>
+          </a:p>
+        </p:txBody>
+      </p:sp>
+      <p:sp>
+        <p:nvSpPr>
+          <p:cNvPr id="5" name="Date Placeholder 4"/>
+          <p:cNvSpPr>
+            <a:spLocks noGrp="1"/>
+          </p:cNvSpPr>
+          <p:nvPr>
+            <p:ph type="dt" sz="half" idx="10"/>
+          </p:nvPr>
+        </p:nvSpPr>
+        <p:spPr/>
+        <p:txBody>
+          <a:bodyPr/>
+          <a:lstStyle/>
+          <a:p>
+            <a:fld id="{241EB5C9-1307-BA42-ABA2-0BC069CD8E7F}" type="datetimeFigureOut">
               <a:rPr lang="en-US" smtClean="0"/>
-              <a:t>Click to edit Master text styles</a:t>
-            </a:r>
-          </a:p>
-        </p:txBody>
-      </p:sp>
-      <p:sp>
-        <p:nvSpPr>
-          <p:cNvPr id="5" name="Date Placeholder 4"/>
-          <p:cNvSpPr>
-            <a:spLocks noGrp="1"/>
-          </p:cNvSpPr>
-          <p:nvPr>
-            <p:ph type="dt" sz="half" idx="10"/>
-          </p:nvPr>
-        </p:nvSpPr>
-        <p:spPr/>
-        <p:txBody>
-          <a:bodyPr/>
-          <a:lstStyle/>
-          <a:p>
-            <a:fld id="{5BCAD085-E8A6-8845-BD4E-CB4CCA059FC4}" type="datetimeFigureOut">
-              <a:rPr lang="en-US" smtClean="0"/>
-              <a:t>1/27/13</a:t>
+              <a:t>1/2/22</a:t>
             </a:fld>
             <a:endParaRPr lang="en-US"/>
           </a:p>
@@ -2558,7 +2556,7 @@
           <a:bodyPr/>
           <a:lstStyle/>
           <a:p>
-            <a:fld id="{C1FF6DA9-008F-8B48-92A6-B652298478BF}" type="slidenum">
+            <a:fld id="{C5EF2332-01BF-834F-8236-50238282D533}" type="slidenum">
               <a:rPr lang="en-US" smtClean="0"/>
               <a:t>‹#›</a:t>
             </a:fld>
@@ -2569,7 +2567,7 @@
     </p:spTree>
     <p:extLst>
       <p:ext uri="{BB962C8B-B14F-4D97-AF65-F5344CB8AC3E}">
-        <p14:creationId xmlns:p14="http://schemas.microsoft.com/office/powerpoint/2010/main" val="3889236939"/>
+        <p14:creationId xmlns:p14="http://schemas.microsoft.com/office/powerpoint/2010/main" val="3566899855"/>
       </p:ext>
     </p:extLst>
   </p:cSld>
@@ -2580,7 +2578,7 @@
 </file>
 
 <file path=ppt/slideMasters/slideMaster1.xml><?xml version="1.0" encoding="utf-8"?>
-<p:sldMaster xmlns:a="http://schemas.openxmlformats.org/drawingml/2006/main" xmlns:r="http://schemas.openxmlformats.org/officeDocument/2006/relationships" xmlns:p="http://schemas.openxmlformats.org/presentationml/2006/main">
+<p:sldMaster xmlns:a="http://schemas.openxmlformats.org/drawingml/2006/main" xmlns:p="http://schemas.openxmlformats.org/presentationml/2006/main" xmlns:r="http://schemas.openxmlformats.org/officeDocument/2006/relationships">
   <p:cSld>
     <p:bg>
       <p:bgRef idx="1001">
@@ -2613,24 +2611,23 @@
         </p:nvSpPr>
         <p:spPr>
           <a:xfrm>
-            <a:off x="457200" y="274638"/>
-            <a:ext cx="8229600" cy="1143000"/>
+            <a:off x="457200" y="205979"/>
+            <a:ext cx="8229600" cy="857250"/>
           </a:xfrm>
           <a:prstGeom prst="rect">
             <a:avLst/>
           </a:prstGeom>
         </p:spPr>
         <p:txBody>
-          <a:bodyPr vert="horz" lIns="91440" tIns="45720" rIns="91440" bIns="45720" rtlCol="0" anchor="ctr">
+          <a:bodyPr anchor="ctr" bIns="45720" lIns="91440" rIns="91440" rtlCol="0" tIns="45720" vert="horz">
             <a:normAutofit/>
           </a:bodyPr>
           <a:lstStyle/>
           <a:p>
             <a:r>
-              <a:rPr lang="en-US" smtClean="0"/>
+              <a:rPr lang="en-US"/>
               <a:t>Click to edit Master title style</a:t>
             </a:r>
-            <a:endParaRPr lang="en-US"/>
           </a:p>
         </p:txBody>
       </p:sp>
@@ -2641,58 +2638,57 @@
             <a:spLocks noGrp="1"/>
           </p:cNvSpPr>
           <p:nvPr>
-            <p:ph type="body" idx="1"/>
+            <p:ph idx="1" type="body"/>
           </p:nvPr>
         </p:nvSpPr>
         <p:spPr>
           <a:xfrm>
-            <a:off x="457200" y="1600200"/>
-            <a:ext cx="8229600" cy="4525963"/>
+            <a:off x="457200" y="1200151"/>
+            <a:ext cx="8229600" cy="3394472"/>
           </a:xfrm>
           <a:prstGeom prst="rect">
             <a:avLst/>
           </a:prstGeom>
         </p:spPr>
         <p:txBody>
-          <a:bodyPr vert="horz" lIns="91440" tIns="45720" rIns="91440" bIns="45720" rtlCol="0">
+          <a:bodyPr bIns="45720" lIns="91440" rIns="91440" rtlCol="0" tIns="45720" vert="horz">
             <a:normAutofit/>
           </a:bodyPr>
           <a:lstStyle/>
           <a:p>
             <a:pPr lvl="0"/>
             <a:r>
-              <a:rPr lang="en-US" smtClean="0"/>
+              <a:rPr lang="en-US"/>
               <a:t>Click to edit Master text styles</a:t>
             </a:r>
           </a:p>
           <a:p>
             <a:pPr lvl="1"/>
             <a:r>
-              <a:rPr lang="en-US" smtClean="0"/>
+              <a:rPr lang="en-US"/>
               <a:t>Second level</a:t>
             </a:r>
           </a:p>
           <a:p>
             <a:pPr lvl="2"/>
             <a:r>
-              <a:rPr lang="en-US" smtClean="0"/>
+              <a:rPr lang="en-US"/>
               <a:t>Third level</a:t>
             </a:r>
           </a:p>
           <a:p>
             <a:pPr lvl="3"/>
             <a:r>
-              <a:rPr lang="en-US" smtClean="0"/>
+              <a:rPr lang="en-US"/>
               <a:t>Fourth level</a:t>
             </a:r>
           </a:p>
           <a:p>
             <a:pPr lvl="4"/>
             <a:r>
-              <a:rPr lang="en-US" smtClean="0"/>
+              <a:rPr lang="en-US"/>
               <a:t>Fifth level</a:t>
             </a:r>
-            <a:endParaRPr lang="en-US"/>
           </a:p>
         </p:txBody>
       </p:sp>
@@ -2703,23 +2699,23 @@
             <a:spLocks noGrp="1"/>
           </p:cNvSpPr>
           <p:nvPr>
-            <p:ph type="dt" sz="half" idx="2"/>
+            <p:ph idx="2" sz="half" type="dt"/>
           </p:nvPr>
         </p:nvSpPr>
         <p:spPr>
           <a:xfrm>
-            <a:off x="457200" y="6356350"/>
-            <a:ext cx="2133600" cy="365125"/>
+            <a:off x="457200" y="4767263"/>
+            <a:ext cx="2133600" cy="273844"/>
           </a:xfrm>
           <a:prstGeom prst="rect">
             <a:avLst/>
           </a:prstGeom>
         </p:spPr>
         <p:txBody>
-          <a:bodyPr vert="horz" lIns="91440" tIns="45720" rIns="91440" bIns="45720" rtlCol="0" anchor="ctr"/>
+          <a:bodyPr anchor="ctr" bIns="45720" lIns="91440" rIns="91440" rtlCol="0" tIns="45720" vert="horz"/>
           <a:lstStyle>
             <a:lvl1pPr algn="l">
-              <a:defRPr sz="1200">
+              <a:defRPr sz="900">
                 <a:solidFill>
                   <a:schemeClr val="tx1">
                     <a:tint val="75000"/>
@@ -2729,9 +2725,9 @@
             </a:lvl1pPr>
           </a:lstStyle>
           <a:p>
-            <a:fld id="{5BCAD085-E8A6-8845-BD4E-CB4CCA059FC4}" type="datetimeFigureOut">
+            <a:fld id="{241EB5C9-1307-BA42-ABA2-0BC069CD8E7F}" type="datetimeFigureOut">
               <a:rPr lang="en-US" smtClean="0"/>
-              <a:t>1/27/13</a:t>
+              <a:t>1/2/22</a:t>
             </a:fld>
             <a:endParaRPr lang="en-US"/>
           </a:p>
@@ -2744,23 +2740,23 @@
             <a:spLocks noGrp="1"/>
           </p:cNvSpPr>
           <p:nvPr>
-            <p:ph type="ftr" sz="quarter" idx="3"/>
+            <p:ph idx="3" sz="quarter" type="ftr"/>
           </p:nvPr>
         </p:nvSpPr>
         <p:spPr>
           <a:xfrm>
-            <a:off x="3124200" y="6356350"/>
-            <a:ext cx="2895600" cy="365125"/>
+            <a:off x="3124200" y="4767263"/>
+            <a:ext cx="2895600" cy="273844"/>
           </a:xfrm>
           <a:prstGeom prst="rect">
             <a:avLst/>
           </a:prstGeom>
         </p:spPr>
         <p:txBody>
-          <a:bodyPr vert="horz" lIns="91440" tIns="45720" rIns="91440" bIns="45720" rtlCol="0" anchor="ctr"/>
+          <a:bodyPr anchor="ctr" bIns="45720" lIns="91440" rIns="91440" rtlCol="0" tIns="45720" vert="horz"/>
           <a:lstStyle>
             <a:lvl1pPr algn="ctr">
-              <a:defRPr sz="1200">
+              <a:defRPr sz="900">
                 <a:solidFill>
                   <a:schemeClr val="tx1">
                     <a:tint val="75000"/>
@@ -2781,23 +2777,23 @@
             <a:spLocks noGrp="1"/>
           </p:cNvSpPr>
           <p:nvPr>
-            <p:ph type="sldNum" sz="quarter" idx="4"/>
+            <p:ph idx="4" sz="quarter" type="sldNum"/>
           </p:nvPr>
         </p:nvSpPr>
         <p:spPr>
           <a:xfrm>
-            <a:off x="6553200" y="6356350"/>
-            <a:ext cx="2133600" cy="365125"/>
+            <a:off x="6553200" y="4767263"/>
+            <a:ext cx="2133600" cy="273844"/>
           </a:xfrm>
           <a:prstGeom prst="rect">
             <a:avLst/>
           </a:prstGeom>
         </p:spPr>
         <p:txBody>
-          <a:bodyPr vert="horz" lIns="91440" tIns="45720" rIns="91440" bIns="45720" rtlCol="0" anchor="ctr"/>
+          <a:bodyPr anchor="ctr" bIns="45720" lIns="91440" rIns="91440" rtlCol="0" tIns="45720" vert="horz"/>
           <a:lstStyle>
             <a:lvl1pPr algn="r">
-              <a:defRPr sz="1200">
+              <a:defRPr sz="900">
                 <a:solidFill>
                   <a:schemeClr val="tx1">
                     <a:tint val="75000"/>
@@ -2807,7 +2803,7 @@
             </a:lvl1pPr>
           </a:lstStyle>
           <a:p>
-            <a:fld id="{C1FF6DA9-008F-8B48-92A6-B652298478BF}" type="slidenum">
+            <a:fld id="{C5EF2332-01BF-834F-8236-50238282D533}" type="slidenum">
               <a:rPr lang="en-US" smtClean="0"/>
               <a:t>‹#›</a:t>
             </a:fld>
@@ -2818,11 +2814,11 @@
     </p:spTree>
     <p:extLst>
       <p:ext uri="{BB962C8B-B14F-4D97-AF65-F5344CB8AC3E}">
-        <p14:creationId xmlns:p14="http://schemas.microsoft.com/office/powerpoint/2010/main" val="2209977519"/>
+        <p14:creationId xmlns:p14="http://schemas.microsoft.com/office/powerpoint/2010/main" val="3676200875"/>
       </p:ext>
     </p:extLst>
   </p:cSld>
-  <p:clrMap bg1="lt1" tx1="dk1" bg2="lt2" tx2="dk2" accent1="accent1" accent2="accent2" accent3="accent3" accent4="accent4" accent5="accent5" accent6="accent6" hlink="hlink" folHlink="folHlink"/>
+  <p:clrMap accent1="accent1" accent2="accent2" accent3="accent3" accent4="accent4" accent5="accent5" accent6="accent6" bg1="lt1" bg2="lt2" folHlink="folHlink" hlink="hlink" tx1="dk1" tx2="dk2"/>
   <p:sldLayoutIdLst>
     <p:sldLayoutId id="2147483649" r:id="rId1"/>
     <p:sldLayoutId id="2147483650" r:id="rId2"/>
@@ -2838,12 +2834,12 @@
   </p:sldLayoutIdLst>
   <p:txStyles>
     <p:titleStyle>
-      <a:lvl1pPr algn="ctr" defTabSz="457200" rtl="0" eaLnBrk="1" latinLnBrk="0" hangingPunct="1">
+      <a:lvl1pPr algn="ctr" defTabSz="342900" eaLnBrk="1" hangingPunct="1" latinLnBrk="0" rtl="0">
         <a:spcBef>
           <a:spcPct val="0"/>
         </a:spcBef>
         <a:buNone/>
-        <a:defRPr sz="4400" kern="1200">
+        <a:defRPr kern="1200" sz="3300">
           <a:solidFill>
             <a:schemeClr val="tx1"/>
           </a:solidFill>
@@ -2854,13 +2850,13 @@
       </a:lvl1pPr>
     </p:titleStyle>
     <p:bodyStyle>
-      <a:lvl1pPr marL="342900" indent="-342900" algn="l" defTabSz="457200" rtl="0" eaLnBrk="1" latinLnBrk="0" hangingPunct="1">
+      <a:lvl1pPr algn="l" defTabSz="342900" eaLnBrk="1" hangingPunct="1" indent="-342900" latinLnBrk="0" marL="342900" rtl="0">
         <a:spcBef>
           <a:spcPct val="20000"/>
         </a:spcBef>
         <a:buFont typeface="Arial"/>
         <a:buChar char="•"/>
-        <a:defRPr sz="3200" kern="1200">
+        <a:defRPr kern="1200" sz="2400">
           <a:solidFill>
             <a:schemeClr val="tx1"/>
           </a:solidFill>
@@ -2869,13 +2865,13 @@
           <a:cs typeface="+mn-cs"/>
         </a:defRPr>
       </a:lvl1pPr>
-      <a:lvl2pPr marL="742950" indent="-285750" algn="l" defTabSz="457200" rtl="0" eaLnBrk="1" latinLnBrk="0" hangingPunct="1">
+      <a:lvl2pPr algn="l" defTabSz="342900" eaLnBrk="1" hangingPunct="1" indent="-342900" latinLnBrk="0" marL="685800" rtl="0">
         <a:spcBef>
           <a:spcPct val="20000"/>
         </a:spcBef>
         <a:buFont typeface="Arial"/>
         <a:buChar char="–"/>
-        <a:defRPr sz="2800" kern="1200">
+        <a:defRPr kern="1200" sz="2100">
           <a:solidFill>
             <a:schemeClr val="tx1"/>
           </a:solidFill>
@@ -2884,13 +2880,13 @@
           <a:cs typeface="+mn-cs"/>
         </a:defRPr>
       </a:lvl2pPr>
-      <a:lvl3pPr marL="1143000" indent="-228600" algn="l" defTabSz="457200" rtl="0" eaLnBrk="1" latinLnBrk="0" hangingPunct="1">
+      <a:lvl3pPr algn="l" defTabSz="342900" eaLnBrk="1" hangingPunct="1" indent="-342900" latinLnBrk="0" marL="1028700" rtl="0">
         <a:spcBef>
           <a:spcPct val="20000"/>
         </a:spcBef>
         <a:buFont typeface="Arial"/>
         <a:buChar char="•"/>
-        <a:defRPr sz="2400" kern="1200">
+        <a:defRPr kern="1200" sz="1800">
           <a:solidFill>
             <a:schemeClr val="tx1"/>
           </a:solidFill>
@@ -2899,13 +2895,13 @@
           <a:cs typeface="+mn-cs"/>
         </a:defRPr>
       </a:lvl3pPr>
-      <a:lvl4pPr marL="1600200" indent="-228600" algn="l" defTabSz="457200" rtl="0" eaLnBrk="1" latinLnBrk="0" hangingPunct="1">
+      <a:lvl4pPr algn="l" defTabSz="342900" eaLnBrk="1" hangingPunct="1" indent="-342900" latinLnBrk="0" marL="1371600" rtl="0">
         <a:spcBef>
           <a:spcPct val="20000"/>
         </a:spcBef>
         <a:buFont typeface="Arial"/>
         <a:buChar char="–"/>
-        <a:defRPr sz="2000" kern="1200">
+        <a:defRPr kern="1200" sz="1500">
           <a:solidFill>
             <a:schemeClr val="tx1"/>
           </a:solidFill>
@@ -2914,13 +2910,13 @@
           <a:cs typeface="+mn-cs"/>
         </a:defRPr>
       </a:lvl4pPr>
-      <a:lvl5pPr marL="2057400" indent="-228600" algn="l" defTabSz="457200" rtl="0" eaLnBrk="1" latinLnBrk="0" hangingPunct="1">
+      <a:lvl5pPr algn="l" defTabSz="342900" eaLnBrk="1" hangingPunct="1" indent="-342900" latinLnBrk="0" marL="1714500" rtl="0">
         <a:spcBef>
           <a:spcPct val="20000"/>
         </a:spcBef>
         <a:buFont typeface="Arial"/>
         <a:buChar char="»"/>
-        <a:defRPr sz="2000" kern="1200">
+        <a:defRPr kern="1200" sz="1500">
           <a:solidFill>
             <a:schemeClr val="tx1"/>
           </a:solidFill>
@@ -2929,13 +2925,13 @@
           <a:cs typeface="+mn-cs"/>
         </a:defRPr>
       </a:lvl5pPr>
-      <a:lvl6pPr marL="2514600" indent="-228600" algn="l" defTabSz="457200" rtl="0" eaLnBrk="1" latinLnBrk="0" hangingPunct="1">
+      <a:lvl6pPr algn="l" defTabSz="342900" eaLnBrk="1" hangingPunct="1" indent="-342900" latinLnBrk="0" marL="2057400" rtl="0">
         <a:spcBef>
           <a:spcPct val="20000"/>
         </a:spcBef>
         <a:buFont typeface="Arial"/>
         <a:buChar char="•"/>
-        <a:defRPr sz="2000" kern="1200">
+        <a:defRPr kern="1200" sz="1500">
           <a:solidFill>
             <a:schemeClr val="tx1"/>
           </a:solidFill>
@@ -2944,13 +2940,13 @@
           <a:cs typeface="+mn-cs"/>
         </a:defRPr>
       </a:lvl6pPr>
-      <a:lvl7pPr marL="2971800" indent="-228600" algn="l" defTabSz="457200" rtl="0" eaLnBrk="1" latinLnBrk="0" hangingPunct="1">
+      <a:lvl7pPr algn="l" defTabSz="342900" eaLnBrk="1" hangingPunct="1" indent="-342900" latinLnBrk="0" marL="2400300" rtl="0">
         <a:spcBef>
           <a:spcPct val="20000"/>
         </a:spcBef>
         <a:buFont typeface="Arial"/>
         <a:buChar char="•"/>
-        <a:defRPr sz="2000" kern="1200">
+        <a:defRPr kern="1200" sz="1500">
           <a:solidFill>
             <a:schemeClr val="tx1"/>
           </a:solidFill>
@@ -2959,13 +2955,13 @@
           <a:cs typeface="+mn-cs"/>
         </a:defRPr>
       </a:lvl7pPr>
-      <a:lvl8pPr marL="3429000" indent="-228600" algn="l" defTabSz="457200" rtl="0" eaLnBrk="1" latinLnBrk="0" hangingPunct="1">
+      <a:lvl8pPr algn="l" defTabSz="342900" eaLnBrk="1" hangingPunct="1" indent="-342900" latinLnBrk="0" marL="2743200" rtl="0">
         <a:spcBef>
           <a:spcPct val="20000"/>
         </a:spcBef>
         <a:buFont typeface="Arial"/>
         <a:buChar char="•"/>
-        <a:defRPr sz="2000" kern="1200">
+        <a:defRPr kern="1200" sz="1500">
           <a:solidFill>
             <a:schemeClr val="tx1"/>
           </a:solidFill>
@@ -2974,13 +2970,13 @@
           <a:cs typeface="+mn-cs"/>
         </a:defRPr>
       </a:lvl8pPr>
-      <a:lvl9pPr marL="3886200" indent="-228600" algn="l" defTabSz="457200" rtl="0" eaLnBrk="1" latinLnBrk="0" hangingPunct="1">
+      <a:lvl9pPr algn="l" defTabSz="342900" eaLnBrk="1" hangingPunct="1" indent="-342900" latinLnBrk="0" marL="3086100" rtl="0">
         <a:spcBef>
           <a:spcPct val="20000"/>
         </a:spcBef>
         <a:buFont typeface="Arial"/>
         <a:buChar char="•"/>
-        <a:defRPr sz="2000" kern="1200">
+        <a:defRPr kern="1200" sz="1500">
           <a:solidFill>
             <a:schemeClr val="tx1"/>
           </a:solidFill>
@@ -2994,8 +2990,8 @@
       <a:defPPr>
         <a:defRPr lang="en-US"/>
       </a:defPPr>
-      <a:lvl1pPr marL="0" algn="l" defTabSz="457200" rtl="0" eaLnBrk="1" latinLnBrk="0" hangingPunct="1">
-        <a:defRPr sz="1800" kern="1200">
+      <a:lvl1pPr algn="l" defTabSz="342900" eaLnBrk="1" hangingPunct="1" latinLnBrk="0" marL="0" rtl="0">
+        <a:defRPr kern="1200" sz="1350">
           <a:solidFill>
             <a:schemeClr val="tx1"/>
           </a:solidFill>
@@ -3004,8 +3000,8 @@
           <a:cs typeface="+mn-cs"/>
         </a:defRPr>
       </a:lvl1pPr>
-      <a:lvl2pPr marL="457200" algn="l" defTabSz="457200" rtl="0" eaLnBrk="1" latinLnBrk="0" hangingPunct="1">
-        <a:defRPr sz="1800" kern="1200">
+      <a:lvl2pPr algn="l" defTabSz="342900" eaLnBrk="1" hangingPunct="1" latinLnBrk="0" marL="342900" rtl="0">
+        <a:defRPr kern="1200" sz="1350">
           <a:solidFill>
             <a:schemeClr val="tx1"/>
           </a:solidFill>
@@ -3014,8 +3010,8 @@
           <a:cs typeface="+mn-cs"/>
         </a:defRPr>
       </a:lvl2pPr>
-      <a:lvl3pPr marL="914400" algn="l" defTabSz="457200" rtl="0" eaLnBrk="1" latinLnBrk="0" hangingPunct="1">
-        <a:defRPr sz="1800" kern="1200">
+      <a:lvl3pPr algn="l" defTabSz="342900" eaLnBrk="1" hangingPunct="1" latinLnBrk="0" marL="685800" rtl="0">
+        <a:defRPr kern="1200" sz="1350">
           <a:solidFill>
             <a:schemeClr val="tx1"/>
           </a:solidFill>
@@ -3024,8 +3020,8 @@
           <a:cs typeface="+mn-cs"/>
         </a:defRPr>
       </a:lvl3pPr>
-      <a:lvl4pPr marL="1371600" algn="l" defTabSz="457200" rtl="0" eaLnBrk="1" latinLnBrk="0" hangingPunct="1">
-        <a:defRPr sz="1800" kern="1200">
+      <a:lvl4pPr algn="l" defTabSz="342900" eaLnBrk="1" hangingPunct="1" latinLnBrk="0" marL="1028700" rtl="0">
+        <a:defRPr kern="1200" sz="1350">
           <a:solidFill>
             <a:schemeClr val="tx1"/>
           </a:solidFill>
@@ -3034,8 +3030,8 @@
           <a:cs typeface="+mn-cs"/>
         </a:defRPr>
       </a:lvl4pPr>
-      <a:lvl5pPr marL="1828800" algn="l" defTabSz="457200" rtl="0" eaLnBrk="1" latinLnBrk="0" hangingPunct="1">
-        <a:defRPr sz="1800" kern="1200">
+      <a:lvl5pPr algn="l" defTabSz="342900" eaLnBrk="1" hangingPunct="1" latinLnBrk="0" marL="1371600" rtl="0">
+        <a:defRPr kern="1200" sz="1350">
           <a:solidFill>
             <a:schemeClr val="tx1"/>
           </a:solidFill>
@@ -3044,8 +3040,8 @@
           <a:cs typeface="+mn-cs"/>
         </a:defRPr>
       </a:lvl5pPr>
-      <a:lvl6pPr marL="2286000" algn="l" defTabSz="457200" rtl="0" eaLnBrk="1" latinLnBrk="0" hangingPunct="1">
-        <a:defRPr sz="1800" kern="1200">
+      <a:lvl6pPr algn="l" defTabSz="342900" eaLnBrk="1" hangingPunct="1" latinLnBrk="0" marL="1714500" rtl="0">
+        <a:defRPr kern="1200" sz="1350">
           <a:solidFill>
             <a:schemeClr val="tx1"/>
           </a:solidFill>
@@ -3054,8 +3050,8 @@
           <a:cs typeface="+mn-cs"/>
         </a:defRPr>
       </a:lvl6pPr>
-      <a:lvl7pPr marL="2743200" algn="l" defTabSz="457200" rtl="0" eaLnBrk="1" latinLnBrk="0" hangingPunct="1">
-        <a:defRPr sz="1800" kern="1200">
+      <a:lvl7pPr algn="l" defTabSz="342900" eaLnBrk="1" hangingPunct="1" latinLnBrk="0" marL="2057400" rtl="0">
+        <a:defRPr kern="1200" sz="1350">
           <a:solidFill>
             <a:schemeClr val="tx1"/>
           </a:solidFill>
@@ -3064,8 +3060,8 @@
           <a:cs typeface="+mn-cs"/>
         </a:defRPr>
       </a:lvl7pPr>
-      <a:lvl8pPr marL="3200400" algn="l" defTabSz="457200" rtl="0" eaLnBrk="1" latinLnBrk="0" hangingPunct="1">
-        <a:defRPr sz="1800" kern="1200">
+      <a:lvl8pPr algn="l" defTabSz="342900" eaLnBrk="1" hangingPunct="1" latinLnBrk="0" marL="2400300" rtl="0">
+        <a:defRPr kern="1200" sz="1350">
           <a:solidFill>
             <a:schemeClr val="tx1"/>
           </a:solidFill>
@@ -3074,8 +3070,8 @@
           <a:cs typeface="+mn-cs"/>
         </a:defRPr>
       </a:lvl8pPr>
-      <a:lvl9pPr marL="3657600" algn="l" defTabSz="457200" rtl="0" eaLnBrk="1" latinLnBrk="0" hangingPunct="1">
-        <a:defRPr sz="1800" kern="1200">
+      <a:lvl9pPr algn="l" defTabSz="342900" eaLnBrk="1" hangingPunct="1" latinLnBrk="0" marL="2743200" rtl="0">
+        <a:defRPr kern="1200" sz="1350">
           <a:solidFill>
             <a:schemeClr val="tx1"/>
           </a:solidFill>
@@ -3090,7 +3086,7 @@
 </file>
 
 <file path=ppt/slides/slide1.xml><?xml version="1.0" encoding="utf-8"?>
-<p:sld xmlns:a="http://schemas.openxmlformats.org/drawingml/2006/main" xmlns:p="http://schemas.openxmlformats.org/presentationml/2006/main" xmlns:r="http://schemas.openxmlformats.org/officeDocument/2006/relationships">
+<p:sld xmlns:a="http://schemas.openxmlformats.org/drawingml/2006/main" xmlns:r="http://schemas.openxmlformats.org/officeDocument/2006/relationships" xmlns:p="http://schemas.openxmlformats.org/presentationml/2006/main">
   <p:cSld>
     <p:spTree>
       <p:nvGrpSpPr>
@@ -3098,7 +3094,14 @@
         <p:cNvGrpSpPr/>
         <p:nvPr/>
       </p:nvGrpSpPr>
-      <p:grpSpPr/>
+      <p:grpSpPr>
+        <a:xfrm>
+          <a:off x="0" y="0"/>
+          <a:ext cx="0" cy="0"/>
+          <a:chOff x="0" y="0"/>
+          <a:chExt cx="0" cy="0"/>
+        </a:xfrm>
+      </p:grpSpPr>
       <p:sp>
         <p:nvSpPr>
           <p:cNvPr id="2" name="Title 1"/>
@@ -3106,51 +3109,66 @@
             <a:spLocks noGrp="1"/>
           </p:cNvSpPr>
           <p:nvPr>
-            <p:ph type="ctrTitle"/>
-          </p:nvPr>
-        </p:nvSpPr>
-        <p:spPr/>
-        <p:txBody>
-          <a:bodyPr/>
-          <a:lstStyle/>
-          <a:p>
-            <a:r>
-              <a:t>Sheng Mouth-Organ Family</a:t>
-            </a:r>
-          </a:p>
-        </p:txBody>
-      </p:sp>
-      <p:sp>
-        <p:nvSpPr>
-          <p:cNvPr id="3" name="Subtitle 2"/>
-          <p:cNvSpPr>
-            <a:spLocks noGrp="1"/>
-          </p:cNvSpPr>
-          <p:nvPr>
-            <p:ph type="subTitle" idx="1"/>
-          </p:nvPr>
-        </p:nvSpPr>
-        <p:spPr/>
-        <p:txBody>
-          <a:bodyPr/>
-          <a:lstStyle/>
-          <a:p>
-            <a:r>
-              <a:t>Scaffold packet, not build-ready.</a:t>
+            <p:ph type="title"/>
+          </p:nvPr>
+        </p:nvSpPr>
+        <p:spPr/>
+        <p:txBody>
+          <a:bodyPr/>
+          <a:lstStyle/>
+          <a:p>
+            <a:pPr lvl="0" indent="0" marL="0">
+              <a:buNone/>
+            </a:pPr>
+            <a:r>
+              <a:rPr/>
+              <a:t>Project Intent</a:t>
+            </a:r>
+          </a:p>
+        </p:txBody>
+      </p:sp>
+      <p:sp>
+        <p:nvSpPr>
+          <p:cNvPr id="3" name="Content Placeholder 2"/>
+          <p:cNvSpPr>
+            <a:spLocks noGrp="1"/>
+          </p:cNvSpPr>
+          <p:nvPr>
+            <p:ph idx="1"/>
+          </p:nvPr>
+        </p:nvSpPr>
+        <p:spPr/>
+        <p:txBody>
+          <a:bodyPr/>
+          <a:lstStyle/>
+          <a:p>
+            <a:pPr lvl="0" indent="0" marL="0">
+              <a:buNone/>
+            </a:pPr>
+            <a:r>
+              <a:rPr/>
+              <a:t>Publish the sheng split from issue #153 and the </a:t>
+            </a:r>
+            <a:r>
+              <a:rPr>
+                <a:latin typeface="Courier"/>
+              </a:rPr>
+              <a:t>tonykoop/sheng</a:t>
+            </a:r>
+            <a:r>
+              <a:rPr/>
+              <a:t> issue #1 starter packet as two explicit packet variants without forcing a premature architecture winner.</a:t>
             </a:r>
           </a:p>
         </p:txBody>
       </p:sp>
     </p:spTree>
   </p:cSld>
-  <p:clrMapOvr>
-    <a:masterClrMapping/>
-  </p:clrMapOvr>
 </p:sld>
 </file>
 
 <file path=ppt/slides/slide10.xml><?xml version="1.0" encoding="utf-8"?>
-<p:sld xmlns:a="http://schemas.openxmlformats.org/drawingml/2006/main" xmlns:p="http://schemas.openxmlformats.org/presentationml/2006/main" xmlns:r="http://schemas.openxmlformats.org/officeDocument/2006/relationships">
+<p:sld xmlns:a="http://schemas.openxmlformats.org/drawingml/2006/main" xmlns:r="http://schemas.openxmlformats.org/officeDocument/2006/relationships" xmlns:p="http://schemas.openxmlformats.org/presentationml/2006/main">
   <p:cSld>
     <p:spTree>
       <p:nvGrpSpPr>
@@ -3158,7 +3176,14 @@
         <p:cNvGrpSpPr/>
         <p:nvPr/>
       </p:nvGrpSpPr>
-      <p:grpSpPr/>
+      <p:grpSpPr>
+        <a:xfrm>
+          <a:off x="0" y="0"/>
+          <a:ext cx="0" cy="0"/>
+          <a:chOff x="0" y="0"/>
+          <a:chExt cx="0" cy="0"/>
+        </a:xfrm>
+      </p:grpSpPr>
       <p:sp>
         <p:nvSpPr>
           <p:cNvPr id="2" name="Title 1"/>
@@ -3174,8 +3199,12 @@
           <a:bodyPr/>
           <a:lstStyle/>
           <a:p>
-            <a:r>
-              <a:t>Status</a:t>
+            <a:pPr lvl="0" indent="0" marL="0">
+              <a:buNone/>
+            </a:pPr>
+            <a:r>
+              <a:rPr/>
+              <a:t>Visual Authority</a:t>
             </a:r>
           </a:p>
         </p:txBody>
@@ -3195,22 +3224,23 @@
           <a:bodyPr/>
           <a:lstStyle/>
           <a:p>
-            <a:r>
-              <a:t>Current packet is scaffold-only and not fabrication authority.</a:t>
+            <a:pPr lvl="0" indent="0" marL="0">
+              <a:buNone/>
+            </a:pPr>
+            <a:r>
+              <a:rPr/>
+              <a:t>Generated images are concept or reference support only.</a:t>
             </a:r>
           </a:p>
         </p:txBody>
       </p:sp>
     </p:spTree>
   </p:cSld>
-  <p:clrMapOvr>
-    <a:masterClrMapping/>
-  </p:clrMapOvr>
 </p:sld>
 </file>
 
 <file path=ppt/slides/slide11.xml><?xml version="1.0" encoding="utf-8"?>
-<p:sld xmlns:a="http://schemas.openxmlformats.org/drawingml/2006/main" xmlns:p="http://schemas.openxmlformats.org/presentationml/2006/main" xmlns:r="http://schemas.openxmlformats.org/officeDocument/2006/relationships">
+<p:sld xmlns:a="http://schemas.openxmlformats.org/drawingml/2006/main" xmlns:r="http://schemas.openxmlformats.org/officeDocument/2006/relationships" xmlns:p="http://schemas.openxmlformats.org/presentationml/2006/main">
   <p:cSld>
     <p:spTree>
       <p:nvGrpSpPr>
@@ -3218,7 +3248,14 @@
         <p:cNvGrpSpPr/>
         <p:nvPr/>
       </p:nvGrpSpPr>
-      <p:grpSpPr/>
+      <p:grpSpPr>
+        <a:xfrm>
+          <a:off x="0" y="0"/>
+          <a:ext cx="0" cy="0"/>
+          <a:chOff x="0" y="0"/>
+          <a:chExt cx="0" cy="0"/>
+        </a:xfrm>
+      </p:grpSpPr>
       <p:sp>
         <p:nvSpPr>
           <p:cNvPr id="2" name="Title 1"/>
@@ -3234,8 +3271,12 @@
           <a:bodyPr/>
           <a:lstStyle/>
           <a:p>
-            <a:r>
-              <a:t>Risks</a:t>
+            <a:pPr lvl="0" indent="0" marL="0">
+              <a:buNone/>
+            </a:pPr>
+            <a:r>
+              <a:rPr/>
+              <a:t>Fabrication Status</a:t>
             </a:r>
           </a:p>
         </p:txBody>
@@ -3255,22 +3296,23 @@
           <a:bodyPr/>
           <a:lstStyle/>
           <a:p>
-            <a:r>
-              <a:t>Unmeasured reed behavior, leakage, and branch mixing.</a:t>
+            <a:pPr lvl="0" indent="0" marL="0">
+              <a:buNone/>
+            </a:pPr>
+            <a:r>
+              <a:rPr/>
+              <a:t>Current status is scaffold. This packet is not build-ready.</a:t>
             </a:r>
           </a:p>
         </p:txBody>
       </p:sp>
     </p:spTree>
   </p:cSld>
-  <p:clrMapOvr>
-    <a:masterClrMapping/>
-  </p:clrMapOvr>
 </p:sld>
 </file>
 
 <file path=ppt/slides/slide12.xml><?xml version="1.0" encoding="utf-8"?>
-<p:sld xmlns:a="http://schemas.openxmlformats.org/drawingml/2006/main" xmlns:p="http://schemas.openxmlformats.org/presentationml/2006/main" xmlns:r="http://schemas.openxmlformats.org/officeDocument/2006/relationships">
+<p:sld xmlns:a="http://schemas.openxmlformats.org/drawingml/2006/main" xmlns:r="http://schemas.openxmlformats.org/officeDocument/2006/relationships" xmlns:p="http://schemas.openxmlformats.org/presentationml/2006/main">
   <p:cSld>
     <p:spTree>
       <p:nvGrpSpPr>
@@ -3278,7 +3320,14 @@
         <p:cNvGrpSpPr/>
         <p:nvPr/>
       </p:nvGrpSpPr>
-      <p:grpSpPr/>
+      <p:grpSpPr>
+        <a:xfrm>
+          <a:off x="0" y="0"/>
+          <a:ext cx="0" cy="0"/>
+          <a:chOff x="0" y="0"/>
+          <a:chExt cx="0" cy="0"/>
+        </a:xfrm>
+      </p:grpSpPr>
       <p:sp>
         <p:nvSpPr>
           <p:cNvPr id="2" name="Title 1"/>
@@ -3294,8 +3343,12 @@
           <a:bodyPr/>
           <a:lstStyle/>
           <a:p>
-            <a:r>
-              <a:t>Next Actions</a:t>
+            <a:pPr lvl="0" indent="0" marL="0">
+              <a:buNone/>
+            </a:pPr>
+            <a:r>
+              <a:rPr/>
+              <a:t>Risks</a:t>
             </a:r>
           </a:p>
         </p:txBody>
@@ -3315,22 +3368,23 @@
           <a:bodyPr/>
           <a:lstStyle/>
           <a:p>
-            <a:r>
-              <a:t>Pick branch, fill coupon log, build single-pipe control, then revise.</a:t>
+            <a:pPr lvl="0" indent="0" marL="0">
+              <a:buNone/>
+            </a:pPr>
+            <a:r>
+              <a:rPr/>
+              <a:t>The primary risks are unmeasured reed behavior, chamber leakage, unsafe pressure testing, and accidental branch mixing.</a:t>
             </a:r>
           </a:p>
         </p:txBody>
       </p:sp>
     </p:spTree>
   </p:cSld>
-  <p:clrMapOvr>
-    <a:masterClrMapping/>
-  </p:clrMapOvr>
 </p:sld>
 </file>
 
-<file path=ppt/slides/slide2.xml><?xml version="1.0" encoding="utf-8"?>
-<p:sld xmlns:a="http://schemas.openxmlformats.org/drawingml/2006/main" xmlns:p="http://schemas.openxmlformats.org/presentationml/2006/main" xmlns:r="http://schemas.openxmlformats.org/officeDocument/2006/relationships">
+<file path=ppt/slides/slide13.xml><?xml version="1.0" encoding="utf-8"?>
+<p:sld xmlns:a="http://schemas.openxmlformats.org/drawingml/2006/main" xmlns:r="http://schemas.openxmlformats.org/officeDocument/2006/relationships" xmlns:p="http://schemas.openxmlformats.org/presentationml/2006/main">
   <p:cSld>
     <p:spTree>
       <p:nvGrpSpPr>
@@ -3338,7 +3392,14 @@
         <p:cNvGrpSpPr/>
         <p:nvPr/>
       </p:nvGrpSpPr>
-      <p:grpSpPr/>
+      <p:grpSpPr>
+        <a:xfrm>
+          <a:off x="0" y="0"/>
+          <a:ext cx="0" cy="0"/>
+          <a:chOff x="0" y="0"/>
+          <a:chExt cx="0" cy="0"/>
+        </a:xfrm>
+      </p:grpSpPr>
       <p:sp>
         <p:nvSpPr>
           <p:cNvPr id="2" name="Title 1"/>
@@ -3354,8 +3415,12 @@
           <a:bodyPr/>
           <a:lstStyle/>
           <a:p>
-            <a:r>
-              <a:t>Branch Decision</a:t>
+            <a:pPr lvl="0" indent="0" marL="0">
+              <a:buNone/>
+            </a:pPr>
+            <a:r>
+              <a:rPr/>
+              <a:t>Next Actions</a:t>
             </a:r>
           </a:p>
         </p:txBody>
@@ -3375,22 +3440,23 @@
           <a:bodyPr/>
           <a:lstStyle/>
           <a:p>
-            <a:r>
-              <a:t>Pick traditional-side-branch or compact-control before layout.</a:t>
+            <a:pPr lvl="0" indent="0" marL="0">
+              <a:buNone/>
+            </a:pPr>
+            <a:r>
+              <a:rPr/>
+              <a:t>Pick a branch, fill the P0 coupon and safety gates, build one single-pipe control, run chamber leak checks, then revise the selected branch sheet with measured evidence.</a:t>
             </a:r>
           </a:p>
         </p:txBody>
       </p:sp>
     </p:spTree>
   </p:cSld>
-  <p:clrMapOvr>
-    <a:masterClrMapping/>
-  </p:clrMapOvr>
 </p:sld>
 </file>
 
-<file path=ppt/slides/slide3.xml><?xml version="1.0" encoding="utf-8"?>
-<p:sld xmlns:a="http://schemas.openxmlformats.org/drawingml/2006/main" xmlns:p="http://schemas.openxmlformats.org/presentationml/2006/main" xmlns:r="http://schemas.openxmlformats.org/officeDocument/2006/relationships">
+<file path=ppt/slides/slide2.xml><?xml version="1.0" encoding="utf-8"?>
+<p:sld xmlns:a="http://schemas.openxmlformats.org/drawingml/2006/main" xmlns:r="http://schemas.openxmlformats.org/officeDocument/2006/relationships" xmlns:p="http://schemas.openxmlformats.org/presentationml/2006/main">
   <p:cSld>
     <p:spTree>
       <p:nvGrpSpPr>
@@ -3398,7 +3464,14 @@
         <p:cNvGrpSpPr/>
         <p:nvPr/>
       </p:nvGrpSpPr>
-      <p:grpSpPr/>
+      <p:grpSpPr>
+        <a:xfrm>
+          <a:off x="0" y="0"/>
+          <a:ext cx="0" cy="0"/>
+          <a:chOff x="0" y="0"/>
+          <a:chExt cx="0" cy="0"/>
+        </a:xfrm>
+      </p:grpSpPr>
       <p:sp>
         <p:nvSpPr>
           <p:cNvPr id="2" name="Title 1"/>
@@ -3414,8 +3487,12 @@
           <a:bodyPr/>
           <a:lstStyle/>
           <a:p>
-            <a:r>
-              <a:t>Traditional Branch</a:t>
+            <a:pPr lvl="0" indent="0" marL="0">
+              <a:buNone/>
+            </a:pPr>
+            <a:r>
+              <a:rPr/>
+              <a:t>Branch Decision</a:t>
             </a:r>
           </a:p>
         </p:txBody>
@@ -3435,22 +3512,43 @@
           <a:bodyPr/>
           <a:lstStyle/>
           <a:p>
-            <a:r>
-              <a:t>side_branch_reed with both_ends_open.</a:t>
+            <a:pPr lvl="0" indent="0" marL="0">
+              <a:buNone/>
+            </a:pPr>
+            <a:r>
+              <a:rPr/>
+              <a:t>The first decision is </a:t>
+            </a:r>
+            <a:r>
+              <a:rPr>
+                <a:latin typeface="Courier"/>
+              </a:rPr>
+              <a:t>traditional-side-branch</a:t>
+            </a:r>
+            <a:r>
+              <a:rPr/>
+              <a:t> versus </a:t>
+            </a:r>
+            <a:r>
+              <a:rPr>
+                <a:latin typeface="Courier"/>
+              </a:rPr>
+              <a:t>compact-control</a:t>
+            </a:r>
+            <a:r>
+              <a:rPr/>
+              <a:t>.</a:t>
             </a:r>
           </a:p>
         </p:txBody>
       </p:sp>
     </p:spTree>
   </p:cSld>
-  <p:clrMapOvr>
-    <a:masterClrMapping/>
-  </p:clrMapOvr>
 </p:sld>
 </file>
 
-<file path=ppt/slides/slide4.xml><?xml version="1.0" encoding="utf-8"?>
-<p:sld xmlns:a="http://schemas.openxmlformats.org/drawingml/2006/main" xmlns:p="http://schemas.openxmlformats.org/presentationml/2006/main" xmlns:r="http://schemas.openxmlformats.org/officeDocument/2006/relationships">
+<file path=ppt/slides/slide3.xml><?xml version="1.0" encoding="utf-8"?>
+<p:sld xmlns:a="http://schemas.openxmlformats.org/drawingml/2006/main" xmlns:r="http://schemas.openxmlformats.org/officeDocument/2006/relationships" xmlns:p="http://schemas.openxmlformats.org/presentationml/2006/main">
   <p:cSld>
     <p:spTree>
       <p:nvGrpSpPr>
@@ -3458,7 +3556,14 @@
         <p:cNvGrpSpPr/>
         <p:nvPr/>
       </p:nvGrpSpPr>
-      <p:grpSpPr/>
+      <p:grpSpPr>
+        <a:xfrm>
+          <a:off x="0" y="0"/>
+          <a:ext cx="0" cy="0"/>
+          <a:chOff x="0" y="0"/>
+          <a:chExt cx="0" cy="0"/>
+        </a:xfrm>
+      </p:grpSpPr>
       <p:sp>
         <p:nvSpPr>
           <p:cNvPr id="2" name="Title 1"/>
@@ -3474,8 +3579,12 @@
           <a:bodyPr/>
           <a:lstStyle/>
           <a:p>
-            <a:r>
-              <a:t>Compact Branch</a:t>
+            <a:pPr lvl="0" indent="0" marL="0">
+              <a:buNone/>
+            </a:pPr>
+            <a:r>
+              <a:rPr/>
+              <a:t>Traditional Branch</a:t>
             </a:r>
           </a:p>
         </p:txBody>
@@ -3495,22 +3604,43 @@
           <a:bodyPr/>
           <a:lstStyle/>
           <a:p>
-            <a:r>
-              <a:t>closed_open with one_end_closed_reed.</a:t>
+            <a:pPr lvl="0" indent="0" marL="0">
+              <a:buNone/>
+            </a:pPr>
+            <a:r>
+              <a:rPr/>
+              <a:t>Traditional side-branch rows use </a:t>
+            </a:r>
+            <a:r>
+              <a:rPr>
+                <a:latin typeface="Courier"/>
+              </a:rPr>
+              <a:t>side_branch_reed</a:t>
+            </a:r>
+            <a:r>
+              <a:rPr/>
+              <a:t> with </a:t>
+            </a:r>
+            <a:r>
+              <a:rPr>
+                <a:latin typeface="Courier"/>
+              </a:rPr>
+              <a:t>end_condition=both_ends_open</a:t>
+            </a:r>
+            <a:r>
+              <a:rPr/>
+              <a:t>.</a:t>
             </a:r>
           </a:p>
         </p:txBody>
       </p:sp>
     </p:spTree>
   </p:cSld>
-  <p:clrMapOvr>
-    <a:masterClrMapping/>
-  </p:clrMapOvr>
 </p:sld>
 </file>
 
-<file path=ppt/slides/slide5.xml><?xml version="1.0" encoding="utf-8"?>
-<p:sld xmlns:a="http://schemas.openxmlformats.org/drawingml/2006/main" xmlns:p="http://schemas.openxmlformats.org/presentationml/2006/main" xmlns:r="http://schemas.openxmlformats.org/officeDocument/2006/relationships">
+<file path=ppt/slides/slide4.xml><?xml version="1.0" encoding="utf-8"?>
+<p:sld xmlns:a="http://schemas.openxmlformats.org/drawingml/2006/main" xmlns:r="http://schemas.openxmlformats.org/officeDocument/2006/relationships" xmlns:p="http://schemas.openxmlformats.org/presentationml/2006/main">
   <p:cSld>
     <p:spTree>
       <p:nvGrpSpPr>
@@ -3518,7 +3648,14 @@
         <p:cNvGrpSpPr/>
         <p:nvPr/>
       </p:nvGrpSpPr>
-      <p:grpSpPr/>
+      <p:grpSpPr>
+        <a:xfrm>
+          <a:off x="0" y="0"/>
+          <a:ext cx="0" cy="0"/>
+          <a:chOff x="0" y="0"/>
+          <a:chExt cx="0" cy="0"/>
+        </a:xfrm>
+      </p:grpSpPr>
       <p:sp>
         <p:nvSpPr>
           <p:cNvPr id="2" name="Title 1"/>
@@ -3534,8 +3671,12 @@
           <a:bodyPr/>
           <a:lstStyle/>
           <a:p>
-            <a:r>
-              <a:t>Family Specs</a:t>
+            <a:pPr lvl="0" indent="0" marL="0">
+              <a:buNone/>
+            </a:pPr>
+            <a:r>
+              <a:rPr/>
+              <a:t>Compact Branch</a:t>
             </a:r>
           </a:p>
         </p:txBody>
@@ -3555,22 +3696,43 @@
           <a:bodyPr/>
           <a:lstStyle/>
           <a:p>
-            <a:r>
-              <a:t>Two separate validator-aligned CSV files.</a:t>
+            <a:pPr lvl="0" indent="0" marL="0">
+              <a:buNone/>
+            </a:pPr>
+            <a:r>
+              <a:rPr/>
+              <a:t>Compact control rows use </a:t>
+            </a:r>
+            <a:r>
+              <a:rPr>
+                <a:latin typeface="Courier"/>
+              </a:rPr>
+              <a:t>closed_open</a:t>
+            </a:r>
+            <a:r>
+              <a:rPr/>
+              <a:t> with </a:t>
+            </a:r>
+            <a:r>
+              <a:rPr>
+                <a:latin typeface="Courier"/>
+              </a:rPr>
+              <a:t>end_condition=one_end_closed_reed</a:t>
+            </a:r>
+            <a:r>
+              <a:rPr/>
+              <a:t>.</a:t>
             </a:r>
           </a:p>
         </p:txBody>
       </p:sp>
     </p:spTree>
   </p:cSld>
-  <p:clrMapOvr>
-    <a:masterClrMapping/>
-  </p:clrMapOvr>
 </p:sld>
 </file>
 
-<file path=ppt/slides/slide6.xml><?xml version="1.0" encoding="utf-8"?>
-<p:sld xmlns:a="http://schemas.openxmlformats.org/drawingml/2006/main" xmlns:p="http://schemas.openxmlformats.org/presentationml/2006/main" xmlns:r="http://schemas.openxmlformats.org/officeDocument/2006/relationships">
+<file path=ppt/slides/slide5.xml><?xml version="1.0" encoding="utf-8"?>
+<p:sld xmlns:a="http://schemas.openxmlformats.org/drawingml/2006/main" xmlns:r="http://schemas.openxmlformats.org/officeDocument/2006/relationships" xmlns:p="http://schemas.openxmlformats.org/presentationml/2006/main">
   <p:cSld>
     <p:spTree>
       <p:nvGrpSpPr>
@@ -3578,7 +3740,14 @@
         <p:cNvGrpSpPr/>
         <p:nvPr/>
       </p:nvGrpSpPr>
-      <p:grpSpPr/>
+      <p:grpSpPr>
+        <a:xfrm>
+          <a:off x="0" y="0"/>
+          <a:ext cx="0" cy="0"/>
+          <a:chOff x="0" y="0"/>
+          <a:chExt cx="0" cy="0"/>
+        </a:xfrm>
+      </p:grpSpPr>
       <p:sp>
         <p:nvSpPr>
           <p:cNvPr id="2" name="Title 1"/>
@@ -3594,8 +3763,12 @@
           <a:bodyPr/>
           <a:lstStyle/>
           <a:p>
-            <a:r>
-              <a:t>Coupon Gate</a:t>
+            <a:pPr lvl="0" indent="0" marL="0">
+              <a:buNone/>
+            </a:pPr>
+            <a:r>
+              <a:rPr/>
+              <a:t>Family Spec</a:t>
             </a:r>
           </a:p>
         </p:txBody>
@@ -3615,22 +3788,33 @@
           <a:bodyPr/>
           <a:lstStyle/>
           <a:p>
-            <a:r>
-              <a:t>Measure reed-alone pitch, onset, blow/draw, gap, and leak status.</a:t>
+            <a:pPr lvl="0" indent="0" marL="0">
+              <a:buNone/>
+            </a:pPr>
+            <a:r>
+              <a:rPr/>
+              <a:t>Each branch has its own </a:t>
+            </a:r>
+            <a:r>
+              <a:rPr>
+                <a:latin typeface="Courier"/>
+              </a:rPr>
+              <a:t>family-spec.csv</a:t>
+            </a:r>
+            <a:r>
+              <a:rPr/>
+              <a:t>. The sheets must stay separate unless measurements prove a shared acoustic model.</a:t>
             </a:r>
           </a:p>
         </p:txBody>
       </p:sp>
     </p:spTree>
   </p:cSld>
-  <p:clrMapOvr>
-    <a:masterClrMapping/>
-  </p:clrMapOvr>
 </p:sld>
 </file>
 
-<file path=ppt/slides/slide7.xml><?xml version="1.0" encoding="utf-8"?>
-<p:sld xmlns:a="http://schemas.openxmlformats.org/drawingml/2006/main" xmlns:p="http://schemas.openxmlformats.org/presentationml/2006/main" xmlns:r="http://schemas.openxmlformats.org/officeDocument/2006/relationships">
+<file path=ppt/slides/slide6.xml><?xml version="1.0" encoding="utf-8"?>
+<p:sld xmlns:a="http://schemas.openxmlformats.org/drawingml/2006/main" xmlns:r="http://schemas.openxmlformats.org/officeDocument/2006/relationships" xmlns:p="http://schemas.openxmlformats.org/presentationml/2006/main">
   <p:cSld>
     <p:spTree>
       <p:nvGrpSpPr>
@@ -3638,7 +3822,14 @@
         <p:cNvGrpSpPr/>
         <p:nvPr/>
       </p:nvGrpSpPr>
-      <p:grpSpPr/>
+      <p:grpSpPr>
+        <a:xfrm>
+          <a:off x="0" y="0"/>
+          <a:ext cx="0" cy="0"/>
+          <a:chOff x="0" y="0"/>
+          <a:chExt cx="0" cy="0"/>
+        </a:xfrm>
+      </p:grpSpPr>
       <p:sp>
         <p:nvSpPr>
           <p:cNvPr id="2" name="Title 1"/>
@@ -3654,8 +3845,12 @@
           <a:bodyPr/>
           <a:lstStyle/>
           <a:p>
-            <a:r>
-              <a:t>Single-Pipe Gate</a:t>
+            <a:pPr lvl="0" indent="0" marL="0">
+              <a:buNone/>
+            </a:pPr>
+            <a:r>
+              <a:rPr/>
+              <a:t>Coupon Gate</a:t>
             </a:r>
           </a:p>
         </p:txBody>
@@ -3675,22 +3870,23 @@
           <a:bodyPr/>
           <a:lstStyle/>
           <a:p>
-            <a:r>
-              <a:t>Validate one pipe before full sheng body layout.</a:t>
+            <a:pPr lvl="0" indent="0" marL="0">
+              <a:buNone/>
+            </a:pPr>
+            <a:r>
+              <a:rPr/>
+              <a:t>The P0 reed coupon records reed-alone pitch, onset pressure, blow/draw behavior, gap, window size, pull-down behavior, retention, and leak status.</a:t>
             </a:r>
           </a:p>
         </p:txBody>
       </p:sp>
     </p:spTree>
   </p:cSld>
-  <p:clrMapOvr>
-    <a:masterClrMapping/>
-  </p:clrMapOvr>
 </p:sld>
 </file>
 
-<file path=ppt/slides/slide8.xml><?xml version="1.0" encoding="utf-8"?>
-<p:sld xmlns:a="http://schemas.openxmlformats.org/drawingml/2006/main" xmlns:p="http://schemas.openxmlformats.org/presentationml/2006/main" xmlns:r="http://schemas.openxmlformats.org/officeDocument/2006/relationships">
+<file path=ppt/slides/slide7.xml><?xml version="1.0" encoding="utf-8"?>
+<p:sld xmlns:a="http://schemas.openxmlformats.org/drawingml/2006/main" xmlns:r="http://schemas.openxmlformats.org/officeDocument/2006/relationships" xmlns:p="http://schemas.openxmlformats.org/presentationml/2006/main">
   <p:cSld>
     <p:spTree>
       <p:nvGrpSpPr>
@@ -3698,7 +3894,14 @@
         <p:cNvGrpSpPr/>
         <p:nvPr/>
       </p:nvGrpSpPr>
-      <p:grpSpPr/>
+      <p:grpSpPr>
+        <a:xfrm>
+          <a:off x="0" y="0"/>
+          <a:ext cx="0" cy="0"/>
+          <a:chOff x="0" y="0"/>
+          <a:chExt cx="0" cy="0"/>
+        </a:xfrm>
+      </p:grpSpPr>
       <p:sp>
         <p:nvSpPr>
           <p:cNvPr id="2" name="Title 1"/>
@@ -3714,8 +3917,12 @@
           <a:bodyPr/>
           <a:lstStyle/>
           <a:p>
-            <a:r>
-              <a:t>Drawing Authority</a:t>
+            <a:pPr lvl="0" indent="0" marL="0">
+              <a:buNone/>
+            </a:pPr>
+            <a:r>
+              <a:rPr/>
+              <a:t>Single-Pipe Gate</a:t>
             </a:r>
           </a:p>
         </p:txBody>
@@ -3735,22 +3942,23 @@
           <a:bodyPr/>
           <a:lstStyle/>
           <a:p>
-            <a:r>
-              <a:t>Future DXF/CAD must name branch, socket map, gasket, and service access.</a:t>
+            <a:pPr lvl="0" indent="0" marL="0">
+              <a:buNone/>
+            </a:pPr>
+            <a:r>
+              <a:rPr/>
+              <a:t>One measured single-pipe control comes before any full mouth-organ body layout.</a:t>
             </a:r>
           </a:p>
         </p:txBody>
       </p:sp>
     </p:spTree>
   </p:cSld>
-  <p:clrMapOvr>
-    <a:masterClrMapping/>
-  </p:clrMapOvr>
 </p:sld>
 </file>
 
-<file path=ppt/slides/slide9.xml><?xml version="1.0" encoding="utf-8"?>
-<p:sld xmlns:a="http://schemas.openxmlformats.org/drawingml/2006/main" xmlns:p="http://schemas.openxmlformats.org/presentationml/2006/main" xmlns:r="http://schemas.openxmlformats.org/officeDocument/2006/relationships">
+<file path=ppt/slides/slide8.xml><?xml version="1.0" encoding="utf-8"?>
+<p:sld xmlns:a="http://schemas.openxmlformats.org/drawingml/2006/main" xmlns:r="http://schemas.openxmlformats.org/officeDocument/2006/relationships" xmlns:p="http://schemas.openxmlformats.org/presentationml/2006/main">
   <p:cSld>
     <p:spTree>
       <p:nvGrpSpPr>
@@ -3758,7 +3966,14 @@
         <p:cNvGrpSpPr/>
         <p:nvPr/>
       </p:nvGrpSpPr>
-      <p:grpSpPr/>
+      <p:grpSpPr>
+        <a:xfrm>
+          <a:off x="0" y="0"/>
+          <a:ext cx="0" cy="0"/>
+          <a:chOff x="0" y="0"/>
+          <a:chExt cx="0" cy="0"/>
+        </a:xfrm>
+      </p:grpSpPr>
       <p:sp>
         <p:nvSpPr>
           <p:cNvPr id="2" name="Title 1"/>
@@ -3774,8 +3989,12 @@
           <a:bodyPr/>
           <a:lstStyle/>
           <a:p>
-            <a:r>
-              <a:t>Visual Authority</a:t>
+            <a:pPr lvl="0" indent="0" marL="0">
+              <a:buNone/>
+            </a:pPr>
+            <a:r>
+              <a:rPr/>
+              <a:t>Windchest Gate</a:t>
             </a:r>
           </a:p>
         </p:txBody>
@@ -3795,17 +4014,90 @@
           <a:bodyPr/>
           <a:lstStyle/>
           <a:p>
-            <a:r>
-              <a:t>Generated images are concept or reference support only.</a:t>
+            <a:pPr lvl="0" indent="0" marL="0">
+              <a:buNone/>
+            </a:pPr>
+            <a:r>
+              <a:rPr/>
+              <a:t>Chamber volume, pressure tap, gasket land, inlet, service access, and leak method stay in planning tables until measured evidence exists.</a:t>
             </a:r>
           </a:p>
         </p:txBody>
       </p:sp>
     </p:spTree>
   </p:cSld>
-  <p:clrMapOvr>
-    <a:masterClrMapping/>
-  </p:clrMapOvr>
+</p:sld>
+</file>
+
+<file path=ppt/slides/slide9.xml><?xml version="1.0" encoding="utf-8"?>
+<p:sld xmlns:a="http://schemas.openxmlformats.org/drawingml/2006/main" xmlns:r="http://schemas.openxmlformats.org/officeDocument/2006/relationships" xmlns:p="http://schemas.openxmlformats.org/presentationml/2006/main">
+  <p:cSld>
+    <p:spTree>
+      <p:nvGrpSpPr>
+        <p:cNvPr id="1" name=""/>
+        <p:cNvGrpSpPr/>
+        <p:nvPr/>
+      </p:nvGrpSpPr>
+      <p:grpSpPr>
+        <a:xfrm>
+          <a:off x="0" y="0"/>
+          <a:ext cx="0" cy="0"/>
+          <a:chOff x="0" y="0"/>
+          <a:chExt cx="0" cy="0"/>
+        </a:xfrm>
+      </p:grpSpPr>
+      <p:sp>
+        <p:nvSpPr>
+          <p:cNvPr id="2" name="Title 1"/>
+          <p:cNvSpPr>
+            <a:spLocks noGrp="1"/>
+          </p:cNvSpPr>
+          <p:nvPr>
+            <p:ph type="title"/>
+          </p:nvPr>
+        </p:nvSpPr>
+        <p:spPr/>
+        <p:txBody>
+          <a:bodyPr/>
+          <a:lstStyle/>
+          <a:p>
+            <a:pPr lvl="0" indent="0" marL="0">
+              <a:buNone/>
+            </a:pPr>
+            <a:r>
+              <a:rPr/>
+              <a:t>Drawing Authority</a:t>
+            </a:r>
+          </a:p>
+        </p:txBody>
+      </p:sp>
+      <p:sp>
+        <p:nvSpPr>
+          <p:cNvPr id="3" name="Content Placeholder 2"/>
+          <p:cNvSpPr>
+            <a:spLocks noGrp="1"/>
+          </p:cNvSpPr>
+          <p:nvPr>
+            <p:ph idx="1"/>
+          </p:nvPr>
+        </p:nvSpPr>
+        <p:spPr/>
+        <p:txBody>
+          <a:bodyPr/>
+          <a:lstStyle/>
+          <a:p>
+            <a:pPr lvl="0" indent="0" marL="0">
+              <a:buNone/>
+            </a:pPr>
+            <a:r>
+              <a:rPr/>
+              <a:t>Future DXF/CAD must name branch, reed window, socket map, gasket land, windchest section, and service direction.</a:t>
+            </a:r>
+          </a:p>
+        </p:txBody>
+      </p:sp>
+    </p:spTree>
+  </p:cSld>
 </p:sld>
 </file>
 
@@ -4127,4 +4419,265 @@
   </a:objectDefaults>
   <a:extraClrSchemeLst/>
 </a:theme>
+</file>
+
+<file path=ppt/theme/theme2.xml><?xml version="1.0" encoding="utf-8"?>
+<a:theme xmlns:a="http://schemas.openxmlformats.org/drawingml/2006/main" name="Office Theme">
+  <a:themeElements>
+    <a:clrScheme name="Office">
+      <a:dk1>
+        <a:sysClr val="windowText" lastClr="000000"/>
+      </a:dk1>
+      <a:lt1>
+        <a:sysClr val="window" lastClr="FFFFFF"/>
+      </a:lt1>
+      <a:dk2>
+        <a:srgbClr val="44546A"/>
+      </a:dk2>
+      <a:lt2>
+        <a:srgbClr val="E7E6E6"/>
+      </a:lt2>
+      <a:accent1>
+        <a:srgbClr val="5B9BD5"/>
+      </a:accent1>
+      <a:accent2>
+        <a:srgbClr val="ED7D31"/>
+      </a:accent2>
+      <a:accent3>
+        <a:srgbClr val="A5A5A5"/>
+      </a:accent3>
+      <a:accent4>
+        <a:srgbClr val="FFC000"/>
+      </a:accent4>
+      <a:accent5>
+        <a:srgbClr val="4472C4"/>
+      </a:accent5>
+      <a:accent6>
+        <a:srgbClr val="70AD47"/>
+      </a:accent6>
+      <a:hlink>
+        <a:srgbClr val="0563C1"/>
+      </a:hlink>
+      <a:folHlink>
+        <a:srgbClr val="954F72"/>
+      </a:folHlink>
+    </a:clrScheme>
+    <a:fontScheme name="Office">
+      <a:majorFont>
+        <a:latin typeface="Calibri Light" panose="020F0302020204030204"/>
+        <a:ea typeface=""/>
+        <a:cs typeface=""/>
+        <a:font script="Jpan" typeface="ＭＳ Ｐゴシック"/>
+        <a:font script="Hang" typeface="맑은 고딕"/>
+        <a:font script="Hans" typeface="宋体"/>
+        <a:font script="Hant" typeface="新細明體"/>
+        <a:font script="Arab" typeface="Times New Roman"/>
+        <a:font script="Hebr" typeface="Times New Roman"/>
+        <a:font script="Thai" typeface="Angsana New"/>
+        <a:font script="Ethi" typeface="Nyala"/>
+        <a:font script="Beng" typeface="Vrinda"/>
+        <a:font script="Gujr" typeface="Shruti"/>
+        <a:font script="Khmr" typeface="MoolBoran"/>
+        <a:font script="Knda" typeface="Tunga"/>
+        <a:font script="Guru" typeface="Raavi"/>
+        <a:font script="Cans" typeface="Euphemia"/>
+        <a:font script="Cher" typeface="Plantagenet Cherokee"/>
+        <a:font script="Yiii" typeface="Microsoft Yi Baiti"/>
+        <a:font script="Tibt" typeface="Microsoft Himalaya"/>
+        <a:font script="Thaa" typeface="MV Boli"/>
+        <a:font script="Deva" typeface="Mangal"/>
+        <a:font script="Telu" typeface="Gautami"/>
+        <a:font script="Taml" typeface="Latha"/>
+        <a:font script="Syrc" typeface="Estrangelo Edessa"/>
+        <a:font script="Orya" typeface="Kalinga"/>
+        <a:font script="Mlym" typeface="Kartika"/>
+        <a:font script="Laoo" typeface="DokChampa"/>
+        <a:font script="Sinh" typeface="Iskoola Pota"/>
+        <a:font script="Mong" typeface="Mongolian Baiti"/>
+        <a:font script="Viet" typeface="Times New Roman"/>
+        <a:font script="Uigh" typeface="Microsoft Uighur"/>
+        <a:font script="Geor" typeface="Sylfaen"/>
+      </a:majorFont>
+      <a:minorFont>
+        <a:latin typeface="Calibri" panose="020F0502020204030204"/>
+        <a:ea typeface=""/>
+        <a:cs typeface=""/>
+        <a:font script="Jpan" typeface="ＭＳ Ｐゴシック"/>
+        <a:font script="Hang" typeface="맑은 고딕"/>
+        <a:font script="Hans" typeface="宋体"/>
+        <a:font script="Hant" typeface="新細明體"/>
+        <a:font script="Arab" typeface="Arial"/>
+        <a:font script="Hebr" typeface="Arial"/>
+        <a:font script="Thai" typeface="Cordia New"/>
+        <a:font script="Ethi" typeface="Nyala"/>
+        <a:font script="Beng" typeface="Vrinda"/>
+        <a:font script="Gujr" typeface="Shruti"/>
+        <a:font script="Khmr" typeface="DaunPenh"/>
+        <a:font script="Knda" typeface="Tunga"/>
+        <a:font script="Guru" typeface="Raavi"/>
+        <a:font script="Cans" typeface="Euphemia"/>
+        <a:font script="Cher" typeface="Plantagenet Cherokee"/>
+        <a:font script="Yiii" typeface="Microsoft Yi Baiti"/>
+        <a:font script="Tibt" typeface="Microsoft Himalaya"/>
+        <a:font script="Thaa" typeface="MV Boli"/>
+        <a:font script="Deva" typeface="Mangal"/>
+        <a:font script="Telu" typeface="Gautami"/>
+        <a:font script="Taml" typeface="Latha"/>
+        <a:font script="Syrc" typeface="Estrangelo Edessa"/>
+        <a:font script="Orya" typeface="Kalinga"/>
+        <a:font script="Mlym" typeface="Kartika"/>
+        <a:font script="Laoo" typeface="DokChampa"/>
+        <a:font script="Sinh" typeface="Iskoola Pota"/>
+        <a:font script="Mong" typeface="Mongolian Baiti"/>
+        <a:font script="Viet" typeface="Arial"/>
+        <a:font script="Uigh" typeface="Microsoft Uighur"/>
+        <a:font script="Geor" typeface="Sylfaen"/>
+      </a:minorFont>
+    </a:fontScheme>
+    <a:fmtScheme name="Office">
+      <a:fillStyleLst>
+        <a:solidFill>
+          <a:schemeClr val="phClr"/>
+        </a:solidFill>
+        <a:gradFill rotWithShape="1">
+          <a:gsLst>
+            <a:gs pos="0">
+              <a:schemeClr val="phClr">
+                <a:lumMod val="110000"/>
+                <a:satMod val="105000"/>
+                <a:tint val="67000"/>
+              </a:schemeClr>
+            </a:gs>
+            <a:gs pos="50000">
+              <a:schemeClr val="phClr">
+                <a:lumMod val="105000"/>
+                <a:satMod val="103000"/>
+                <a:tint val="73000"/>
+              </a:schemeClr>
+            </a:gs>
+            <a:gs pos="100000">
+              <a:schemeClr val="phClr">
+                <a:lumMod val="105000"/>
+                <a:satMod val="109000"/>
+                <a:tint val="81000"/>
+              </a:schemeClr>
+            </a:gs>
+          </a:gsLst>
+          <a:lin ang="5400000" scaled="0"/>
+        </a:gradFill>
+        <a:gradFill rotWithShape="1">
+          <a:gsLst>
+            <a:gs pos="0">
+              <a:schemeClr val="phClr">
+                <a:satMod val="103000"/>
+                <a:lumMod val="102000"/>
+                <a:tint val="94000"/>
+              </a:schemeClr>
+            </a:gs>
+            <a:gs pos="50000">
+              <a:schemeClr val="phClr">
+                <a:satMod val="110000"/>
+                <a:lumMod val="100000"/>
+                <a:shade val="100000"/>
+              </a:schemeClr>
+            </a:gs>
+            <a:gs pos="100000">
+              <a:schemeClr val="phClr">
+                <a:lumMod val="99000"/>
+                <a:satMod val="120000"/>
+                <a:shade val="78000"/>
+              </a:schemeClr>
+            </a:gs>
+          </a:gsLst>
+          <a:lin ang="5400000" scaled="0"/>
+        </a:gradFill>
+      </a:fillStyleLst>
+      <a:lnStyleLst>
+        <a:ln w="6350" cap="flat" cmpd="sng" algn="ctr">
+          <a:solidFill>
+            <a:schemeClr val="phClr"/>
+          </a:solidFill>
+          <a:prstDash val="solid"/>
+          <a:miter lim="800000"/>
+        </a:ln>
+        <a:ln w="12700" cap="flat" cmpd="sng" algn="ctr">
+          <a:solidFill>
+            <a:schemeClr val="phClr"/>
+          </a:solidFill>
+          <a:prstDash val="solid"/>
+          <a:miter lim="800000"/>
+        </a:ln>
+        <a:ln w="19050" cap="flat" cmpd="sng" algn="ctr">
+          <a:solidFill>
+            <a:schemeClr val="phClr"/>
+          </a:solidFill>
+          <a:prstDash val="solid"/>
+          <a:miter lim="800000"/>
+        </a:ln>
+      </a:lnStyleLst>
+      <a:effectStyleLst>
+        <a:effectStyle>
+          <a:effectLst/>
+        </a:effectStyle>
+        <a:effectStyle>
+          <a:effectLst/>
+        </a:effectStyle>
+        <a:effectStyle>
+          <a:effectLst>
+            <a:outerShdw blurRad="57150" dist="19050" dir="5400000" algn="ctr" rotWithShape="0">
+              <a:srgbClr val="000000">
+                <a:alpha val="63000"/>
+              </a:srgbClr>
+            </a:outerShdw>
+          </a:effectLst>
+        </a:effectStyle>
+      </a:effectStyleLst>
+      <a:bgFillStyleLst>
+        <a:solidFill>
+          <a:schemeClr val="phClr"/>
+        </a:solidFill>
+        <a:solidFill>
+          <a:schemeClr val="phClr">
+            <a:tint val="95000"/>
+            <a:satMod val="170000"/>
+          </a:schemeClr>
+        </a:solidFill>
+        <a:gradFill rotWithShape="1">
+          <a:gsLst>
+            <a:gs pos="0">
+              <a:schemeClr val="phClr">
+                <a:tint val="93000"/>
+                <a:satMod val="150000"/>
+                <a:shade val="98000"/>
+                <a:lumMod val="102000"/>
+              </a:schemeClr>
+            </a:gs>
+            <a:gs pos="50000">
+              <a:schemeClr val="phClr">
+                <a:tint val="98000"/>
+                <a:satMod val="130000"/>
+                <a:shade val="90000"/>
+                <a:lumMod val="103000"/>
+              </a:schemeClr>
+            </a:gs>
+            <a:gs pos="100000">
+              <a:schemeClr val="phClr">
+                <a:shade val="63000"/>
+                <a:satMod val="120000"/>
+              </a:schemeClr>
+            </a:gs>
+          </a:gsLst>
+          <a:lin ang="5400000" scaled="0"/>
+        </a:gradFill>
+      </a:bgFillStyleLst>
+    </a:fmtScheme>
+  </a:themeElements>
+  <a:objectDefaults/>
+  <a:extraClrSchemeLst/>
+  <a:extLst>
+    <a:ext uri="{05A4C25C-085E-4340-85A3-A5531E510DB2}">
+      <thm15:themeFamily xmlns:thm15="http://schemas.microsoft.com/office/thememl/2012/main" name="Office Theme" id="{62F939B6-93AF-4DB8-9C6B-D6C7DFDC589F}" vid="{4A3C46E8-61CC-4603-A589-7422A47A8E4A}"/>
+    </a:ext>
+  </a:extLst>
+</a:theme>
 </file>
</xml_diff>